<commit_message>
Add Slide 5 (Business Value) and Slide 6 (defence diagram); update slide counters to 6
Co-authored-by: labanlaban <126345013+labanlaban@users.noreply.github.com>
</commit_message>
<xml_diff>
--- a/sms_pumping_defence.pptx
+++ b/sms_pumping_defence.pptx
@@ -9,6 +9,8 @@
     <p:sldId id="257" r:id="rId8"/>
     <p:sldId id="258" r:id="rId9"/>
     <p:sldId id="259" r:id="rId10"/>
+    <p:sldId id="260" r:id="rId11"/>
+    <p:sldId id="261" r:id="rId12"/>
   </p:sldIdLst>
   <p:sldSz cx="12188952" cy="6858000" type="screen4x3"/>
   <p:notesSz cx="6858000" cy="9144000"/>
@@ -3171,7 +3173,7 @@
                   <a:srgbClr val="CCCCCC"/>
                 </a:solidFill>
               </a:rPr>
-              <a:t>Slide 1 of 4</a:t>
+              <a:t>Slide 1 of 6</a:t>
             </a:r>
           </a:p>
         </p:txBody>
@@ -3880,7 +3882,7 @@
                   <a:srgbClr val="CCCCCC"/>
                 </a:solidFill>
               </a:rPr>
-              <a:t>Slide 2 of 4</a:t>
+              <a:t>Slide 2 of 6</a:t>
             </a:r>
           </a:p>
         </p:txBody>
@@ -4521,7 +4523,7 @@
                   <a:srgbClr val="CCCCCC"/>
                 </a:solidFill>
               </a:rPr>
-              <a:t>Slide 3 of 4</a:t>
+              <a:t>Slide 3 of 6</a:t>
             </a:r>
           </a:p>
         </p:txBody>
@@ -5372,7 +5374,7 @@
                   <a:srgbClr val="CCCCCC"/>
                 </a:solidFill>
               </a:rPr>
-              <a:t>Slide 4 of 4</a:t>
+              <a:t>Slide 4 of 6</a:t>
             </a:r>
           </a:p>
         </p:txBody>
@@ -6139,6 +6141,2024 @@
       <p:sp>
         <p:nvSpPr>
           <p:cNvPr id="23" name="TextBox 22"/>
+          <p:cNvSpPr txBox="1"/>
+          <p:nvPr/>
+        </p:nvSpPr>
+        <p:spPr>
+          <a:xfrm>
+            <a:off x="274320" y="6565392"/>
+            <a:ext cx="11887200" cy="256032"/>
+          </a:xfrm>
+          <a:prstGeom prst="rect">
+            <a:avLst/>
+          </a:prstGeom>
+          <a:noFill/>
+        </p:spPr>
+        <p:txBody>
+          <a:bodyPr wrap="square">
+            <a:spAutoFit/>
+          </a:bodyPr>
+          <a:lstStyle/>
+          <a:p>
+            <a:pPr algn="l"/>
+            <a:r>
+              <a:rPr sz="900" b="0" i="0">
+                <a:solidFill>
+                  <a:srgbClr val="CCCCCC"/>
+                </a:solidFill>
+              </a:rPr>
+              <a:t>SMS Pumping Defence  |  Confidential</a:t>
+            </a:r>
+          </a:p>
+        </p:txBody>
+      </p:sp>
+    </p:spTree>
+  </p:cSld>
+  <p:clrMapOvr>
+    <a:masterClrMapping/>
+  </p:clrMapOvr>
+</p:sld>
+</file>
+
+<file path=ppt/slides/slide5.xml><?xml version="1.0" encoding="utf-8"?>
+<p:sld xmlns:a="http://schemas.openxmlformats.org/drawingml/2006/main" xmlns:p="http://schemas.openxmlformats.org/presentationml/2006/main" xmlns:r="http://schemas.openxmlformats.org/officeDocument/2006/relationships">
+  <p:cSld>
+    <p:bg>
+      <p:bgPr>
+        <a:solidFill>
+          <a:srgbClr val="1A1A2E"/>
+        </a:solidFill>
+        <a:effectLst/>
+      </p:bgPr>
+    </p:bg>
+    <p:spTree>
+      <p:nvGrpSpPr>
+        <p:cNvPr id="1" name=""/>
+        <p:cNvGrpSpPr/>
+        <p:nvPr/>
+      </p:nvGrpSpPr>
+      <p:grpSpPr/>
+      <p:sp>
+        <p:nvSpPr>
+          <p:cNvPr id="2" name="Rectangle 1"/>
+          <p:cNvSpPr/>
+          <p:nvPr/>
+        </p:nvSpPr>
+        <p:spPr>
+          <a:xfrm>
+            <a:off x="0" y="0"/>
+            <a:ext cx="12188952" cy="685800"/>
+          </a:xfrm>
+          <a:prstGeom prst="rect">
+            <a:avLst/>
+          </a:prstGeom>
+          <a:solidFill>
+            <a:srgbClr val="0F3D6E"/>
+          </a:solidFill>
+          <a:ln>
+            <a:noFill/>
+          </a:ln>
+        </p:spPr>
+        <p:style>
+          <a:lnRef idx="1">
+            <a:schemeClr val="accent1"/>
+          </a:lnRef>
+          <a:fillRef idx="3">
+            <a:schemeClr val="accent1"/>
+          </a:fillRef>
+          <a:effectRef idx="2">
+            <a:schemeClr val="accent1"/>
+          </a:effectRef>
+          <a:fontRef idx="minor">
+            <a:schemeClr val="lt1"/>
+          </a:fontRef>
+        </p:style>
+        <p:txBody>
+          <a:bodyPr rtlCol="0" anchor="ctr"/>
+          <a:lstStyle/>
+          <a:p>
+            <a:pPr algn="ctr"/>
+          </a:p>
+        </p:txBody>
+      </p:sp>
+      <p:sp>
+        <p:nvSpPr>
+          <p:cNvPr id="3" name="TextBox 2"/>
+          <p:cNvSpPr txBox="1"/>
+          <p:nvPr/>
+        </p:nvSpPr>
+        <p:spPr>
+          <a:xfrm>
+            <a:off x="182880" y="73152"/>
+            <a:ext cx="2743200" cy="457200"/>
+          </a:xfrm>
+          <a:prstGeom prst="rect">
+            <a:avLst/>
+          </a:prstGeom>
+          <a:noFill/>
+        </p:spPr>
+        <p:txBody>
+          <a:bodyPr wrap="square">
+            <a:spAutoFit/>
+          </a:bodyPr>
+          <a:lstStyle/>
+          <a:p>
+            <a:pPr algn="l"/>
+            <a:r>
+              <a:rPr sz="1000" b="0" i="0">
+                <a:solidFill>
+                  <a:srgbClr val="CCCCCC"/>
+                </a:solidFill>
+              </a:rPr>
+              <a:t>Slide 5 of 6</a:t>
+            </a:r>
+          </a:p>
+        </p:txBody>
+      </p:sp>
+      <p:sp>
+        <p:nvSpPr>
+          <p:cNvPr id="4" name="TextBox 3"/>
+          <p:cNvSpPr txBox="1"/>
+          <p:nvPr/>
+        </p:nvSpPr>
+        <p:spPr>
+          <a:xfrm>
+            <a:off x="274320" y="45720"/>
+            <a:ext cx="11430000" cy="640080"/>
+          </a:xfrm>
+          <a:prstGeom prst="rect">
+            <a:avLst/>
+          </a:prstGeom>
+          <a:noFill/>
+        </p:spPr>
+        <p:txBody>
+          <a:bodyPr wrap="square">
+            <a:spAutoFit/>
+          </a:bodyPr>
+          <a:lstStyle/>
+          <a:p>
+            <a:pPr algn="l"/>
+            <a:r>
+              <a:rPr sz="2600" b="1" i="0">
+                <a:solidFill>
+                  <a:srgbClr val="FFFFFF"/>
+                </a:solidFill>
+              </a:rPr>
+              <a:t>Business Value &amp; Next Steps</a:t>
+            </a:r>
+          </a:p>
+        </p:txBody>
+      </p:sp>
+      <p:sp>
+        <p:nvSpPr>
+          <p:cNvPr id="5" name="Rectangle 4"/>
+          <p:cNvSpPr/>
+          <p:nvPr/>
+        </p:nvSpPr>
+        <p:spPr>
+          <a:xfrm>
+            <a:off x="0" y="658368"/>
+            <a:ext cx="12188952" cy="54864"/>
+          </a:xfrm>
+          <a:prstGeom prst="rect">
+            <a:avLst/>
+          </a:prstGeom>
+          <a:solidFill>
+            <a:srgbClr val="E94F37"/>
+          </a:solidFill>
+          <a:ln>
+            <a:noFill/>
+          </a:ln>
+        </p:spPr>
+        <p:style>
+          <a:lnRef idx="1">
+            <a:schemeClr val="accent1"/>
+          </a:lnRef>
+          <a:fillRef idx="3">
+            <a:schemeClr val="accent1"/>
+          </a:fillRef>
+          <a:effectRef idx="2">
+            <a:schemeClr val="accent1"/>
+          </a:effectRef>
+          <a:fontRef idx="minor">
+            <a:schemeClr val="lt1"/>
+          </a:fontRef>
+        </p:style>
+        <p:txBody>
+          <a:bodyPr rtlCol="0" anchor="ctr"/>
+          <a:lstStyle/>
+          <a:p>
+            <a:pPr algn="ctr"/>
+          </a:p>
+        </p:txBody>
+      </p:sp>
+      <p:sp>
+        <p:nvSpPr>
+          <p:cNvPr id="6" name="Rectangle 5"/>
+          <p:cNvSpPr/>
+          <p:nvPr/>
+        </p:nvSpPr>
+        <p:spPr>
+          <a:xfrm>
+            <a:off x="320040" y="1005840"/>
+            <a:ext cx="3749039" cy="5212080"/>
+          </a:xfrm>
+          <a:prstGeom prst="rect">
+            <a:avLst/>
+          </a:prstGeom>
+          <a:solidFill>
+            <a:srgbClr val="0F3D6E"/>
+          </a:solidFill>
+          <a:ln w="19050">
+            <a:solidFill>
+              <a:srgbClr val="E94F37"/>
+            </a:solidFill>
+          </a:ln>
+        </p:spPr>
+        <p:style>
+          <a:lnRef idx="1">
+            <a:schemeClr val="accent1"/>
+          </a:lnRef>
+          <a:fillRef idx="3">
+            <a:schemeClr val="accent1"/>
+          </a:fillRef>
+          <a:effectRef idx="2">
+            <a:schemeClr val="accent1"/>
+          </a:effectRef>
+          <a:fontRef idx="minor">
+            <a:schemeClr val="lt1"/>
+          </a:fontRef>
+        </p:style>
+        <p:txBody>
+          <a:bodyPr rtlCol="0" anchor="ctr"/>
+          <a:lstStyle/>
+          <a:p>
+            <a:pPr algn="ctr"/>
+          </a:p>
+        </p:txBody>
+      </p:sp>
+      <p:sp>
+        <p:nvSpPr>
+          <p:cNvPr id="7" name="Rectangle 6"/>
+          <p:cNvSpPr/>
+          <p:nvPr/>
+        </p:nvSpPr>
+        <p:spPr>
+          <a:xfrm>
+            <a:off x="320040" y="1005840"/>
+            <a:ext cx="3749039" cy="594360"/>
+          </a:xfrm>
+          <a:prstGeom prst="rect">
+            <a:avLst/>
+          </a:prstGeom>
+          <a:solidFill>
+            <a:srgbClr val="E94F37"/>
+          </a:solidFill>
+          <a:ln>
+            <a:noFill/>
+          </a:ln>
+        </p:spPr>
+        <p:style>
+          <a:lnRef idx="1">
+            <a:schemeClr val="accent1"/>
+          </a:lnRef>
+          <a:fillRef idx="3">
+            <a:schemeClr val="accent1"/>
+          </a:fillRef>
+          <a:effectRef idx="2">
+            <a:schemeClr val="accent1"/>
+          </a:effectRef>
+          <a:fontRef idx="minor">
+            <a:schemeClr val="lt1"/>
+          </a:fontRef>
+        </p:style>
+        <p:txBody>
+          <a:bodyPr rtlCol="0" anchor="ctr"/>
+          <a:lstStyle/>
+          <a:p>
+            <a:pPr algn="ctr"/>
+          </a:p>
+        </p:txBody>
+      </p:sp>
+      <p:sp>
+        <p:nvSpPr>
+          <p:cNvPr id="8" name="TextBox 7"/>
+          <p:cNvSpPr txBox="1"/>
+          <p:nvPr/>
+        </p:nvSpPr>
+        <p:spPr>
+          <a:xfrm>
+            <a:off x="484632" y="1069848"/>
+            <a:ext cx="3474720" cy="475488"/>
+          </a:xfrm>
+          <a:prstGeom prst="rect">
+            <a:avLst/>
+          </a:prstGeom>
+          <a:noFill/>
+        </p:spPr>
+        <p:txBody>
+          <a:bodyPr wrap="square">
+            <a:spAutoFit/>
+          </a:bodyPr>
+          <a:lstStyle/>
+          <a:p>
+            <a:pPr algn="l"/>
+            <a:r>
+              <a:rPr sz="1500" b="1" i="0">
+                <a:solidFill>
+                  <a:srgbClr val="FFFFFF"/>
+                </a:solidFill>
+              </a:rPr>
+              <a:t>💰  Immediate ROI</a:t>
+            </a:r>
+          </a:p>
+        </p:txBody>
+      </p:sp>
+      <p:sp>
+        <p:nvSpPr>
+          <p:cNvPr id="9" name="TextBox 8"/>
+          <p:cNvSpPr txBox="1"/>
+          <p:nvPr/>
+        </p:nvSpPr>
+        <p:spPr>
+          <a:xfrm>
+            <a:off x="484632" y="1691640"/>
+            <a:ext cx="3456432" cy="4297680"/>
+          </a:xfrm>
+          <a:prstGeom prst="rect">
+            <a:avLst/>
+          </a:prstGeom>
+          <a:noFill/>
+        </p:spPr>
+        <p:txBody>
+          <a:bodyPr wrap="square">
+            <a:spAutoFit/>
+          </a:bodyPr>
+          <a:lstStyle/>
+          <a:p>
+            <a:pPr algn="l"/>
+            <a:r>
+              <a:rPr sz="1300" b="0" i="0">
+                <a:solidFill>
+                  <a:srgbClr val="FFFFFF"/>
+                </a:solidFill>
+              </a:rPr>
+              <a:t>We have successfully shut off the vulnerability that automated scripts were exploiting, saving the company from runaway Twilio invoices.
+The fix costs nothing to run and protects us indefinitely.</a:t>
+            </a:r>
+          </a:p>
+        </p:txBody>
+      </p:sp>
+      <p:sp>
+        <p:nvSpPr>
+          <p:cNvPr id="10" name="Rectangle 9"/>
+          <p:cNvSpPr/>
+          <p:nvPr/>
+        </p:nvSpPr>
+        <p:spPr>
+          <a:xfrm>
+            <a:off x="4297679" y="1005840"/>
+            <a:ext cx="3749039" cy="5212080"/>
+          </a:xfrm>
+          <a:prstGeom prst="rect">
+            <a:avLst/>
+          </a:prstGeom>
+          <a:solidFill>
+            <a:srgbClr val="0F3D6E"/>
+          </a:solidFill>
+          <a:ln w="19050">
+            <a:solidFill>
+              <a:srgbClr val="E94F37"/>
+            </a:solidFill>
+          </a:ln>
+        </p:spPr>
+        <p:style>
+          <a:lnRef idx="1">
+            <a:schemeClr val="accent1"/>
+          </a:lnRef>
+          <a:fillRef idx="3">
+            <a:schemeClr val="accent1"/>
+          </a:fillRef>
+          <a:effectRef idx="2">
+            <a:schemeClr val="accent1"/>
+          </a:effectRef>
+          <a:fontRef idx="minor">
+            <a:schemeClr val="lt1"/>
+          </a:fontRef>
+        </p:style>
+        <p:txBody>
+          <a:bodyPr rtlCol="0" anchor="ctr"/>
+          <a:lstStyle/>
+          <a:p>
+            <a:pPr algn="ctr"/>
+          </a:p>
+        </p:txBody>
+      </p:sp>
+      <p:sp>
+        <p:nvSpPr>
+          <p:cNvPr id="11" name="Rectangle 10"/>
+          <p:cNvSpPr/>
+          <p:nvPr/>
+        </p:nvSpPr>
+        <p:spPr>
+          <a:xfrm>
+            <a:off x="4297679" y="1005840"/>
+            <a:ext cx="3749039" cy="594360"/>
+          </a:xfrm>
+          <a:prstGeom prst="rect">
+            <a:avLst/>
+          </a:prstGeom>
+          <a:solidFill>
+            <a:srgbClr val="E94F37"/>
+          </a:solidFill>
+          <a:ln>
+            <a:noFill/>
+          </a:ln>
+        </p:spPr>
+        <p:style>
+          <a:lnRef idx="1">
+            <a:schemeClr val="accent1"/>
+          </a:lnRef>
+          <a:fillRef idx="3">
+            <a:schemeClr val="accent1"/>
+          </a:fillRef>
+          <a:effectRef idx="2">
+            <a:schemeClr val="accent1"/>
+          </a:effectRef>
+          <a:fontRef idx="minor">
+            <a:schemeClr val="lt1"/>
+          </a:fontRef>
+        </p:style>
+        <p:txBody>
+          <a:bodyPr rtlCol="0" anchor="ctr"/>
+          <a:lstStyle/>
+          <a:p>
+            <a:pPr algn="ctr"/>
+          </a:p>
+        </p:txBody>
+      </p:sp>
+      <p:sp>
+        <p:nvSpPr>
+          <p:cNvPr id="12" name="TextBox 11"/>
+          <p:cNvSpPr txBox="1"/>
+          <p:nvPr/>
+        </p:nvSpPr>
+        <p:spPr>
+          <a:xfrm>
+            <a:off x="4462271" y="1069848"/>
+            <a:ext cx="3474720" cy="475488"/>
+          </a:xfrm>
+          <a:prstGeom prst="rect">
+            <a:avLst/>
+          </a:prstGeom>
+          <a:noFill/>
+        </p:spPr>
+        <p:txBody>
+          <a:bodyPr wrap="square">
+            <a:spAutoFit/>
+          </a:bodyPr>
+          <a:lstStyle/>
+          <a:p>
+            <a:pPr algn="l"/>
+            <a:r>
+              <a:rPr sz="1500" b="1" i="0">
+                <a:solidFill>
+                  <a:srgbClr val="FFFFFF"/>
+                </a:solidFill>
+              </a:rPr>
+              <a:t>📈  Predictable Scaling</a:t>
+            </a:r>
+          </a:p>
+        </p:txBody>
+      </p:sp>
+      <p:sp>
+        <p:nvSpPr>
+          <p:cNvPr id="13" name="TextBox 12"/>
+          <p:cNvSpPr txBox="1"/>
+          <p:nvPr/>
+        </p:nvSpPr>
+        <p:spPr>
+          <a:xfrm>
+            <a:off x="4462271" y="1691640"/>
+            <a:ext cx="3456432" cy="4297680"/>
+          </a:xfrm>
+          <a:prstGeom prst="rect">
+            <a:avLst/>
+          </a:prstGeom>
+          <a:noFill/>
+        </p:spPr>
+        <p:txBody>
+          <a:bodyPr wrap="square">
+            <a:spAutoFit/>
+          </a:bodyPr>
+          <a:lstStyle/>
+          <a:p>
+            <a:pPr algn="l"/>
+            <a:r>
+              <a:rPr sz="1300" b="0" i="0">
+                <a:solidFill>
+                  <a:srgbClr val="FFFFFF"/>
+                </a:solidFill>
+              </a:rPr>
+              <a:t>As we grow our legitimate user base, our SMS costs will scale directly with real human onboarding — not outside bot traffic.
+Budgeting becomes reliable and tied to actual growth.</a:t>
+            </a:r>
+          </a:p>
+        </p:txBody>
+      </p:sp>
+      <p:sp>
+        <p:nvSpPr>
+          <p:cNvPr id="14" name="Rectangle 13"/>
+          <p:cNvSpPr/>
+          <p:nvPr/>
+        </p:nvSpPr>
+        <p:spPr>
+          <a:xfrm>
+            <a:off x="8275319" y="1005840"/>
+            <a:ext cx="3749039" cy="5212080"/>
+          </a:xfrm>
+          <a:prstGeom prst="rect">
+            <a:avLst/>
+          </a:prstGeom>
+          <a:solidFill>
+            <a:srgbClr val="0F3D6E"/>
+          </a:solidFill>
+          <a:ln w="19050">
+            <a:solidFill>
+              <a:srgbClr val="E94F37"/>
+            </a:solidFill>
+          </a:ln>
+        </p:spPr>
+        <p:style>
+          <a:lnRef idx="1">
+            <a:schemeClr val="accent1"/>
+          </a:lnRef>
+          <a:fillRef idx="3">
+            <a:schemeClr val="accent1"/>
+          </a:fillRef>
+          <a:effectRef idx="2">
+            <a:schemeClr val="accent1"/>
+          </a:effectRef>
+          <a:fontRef idx="minor">
+            <a:schemeClr val="lt1"/>
+          </a:fontRef>
+        </p:style>
+        <p:txBody>
+          <a:bodyPr rtlCol="0" anchor="ctr"/>
+          <a:lstStyle/>
+          <a:p>
+            <a:pPr algn="ctr"/>
+          </a:p>
+        </p:txBody>
+      </p:sp>
+      <p:sp>
+        <p:nvSpPr>
+          <p:cNvPr id="15" name="Rectangle 14"/>
+          <p:cNvSpPr/>
+          <p:nvPr/>
+        </p:nvSpPr>
+        <p:spPr>
+          <a:xfrm>
+            <a:off x="8275319" y="1005840"/>
+            <a:ext cx="3749039" cy="594360"/>
+          </a:xfrm>
+          <a:prstGeom prst="rect">
+            <a:avLst/>
+          </a:prstGeom>
+          <a:solidFill>
+            <a:srgbClr val="E94F37"/>
+          </a:solidFill>
+          <a:ln>
+            <a:noFill/>
+          </a:ln>
+        </p:spPr>
+        <p:style>
+          <a:lnRef idx="1">
+            <a:schemeClr val="accent1"/>
+          </a:lnRef>
+          <a:fillRef idx="3">
+            <a:schemeClr val="accent1"/>
+          </a:fillRef>
+          <a:effectRef idx="2">
+            <a:schemeClr val="accent1"/>
+          </a:effectRef>
+          <a:fontRef idx="minor">
+            <a:schemeClr val="lt1"/>
+          </a:fontRef>
+        </p:style>
+        <p:txBody>
+          <a:bodyPr rtlCol="0" anchor="ctr"/>
+          <a:lstStyle/>
+          <a:p>
+            <a:pPr algn="ctr"/>
+          </a:p>
+        </p:txBody>
+      </p:sp>
+      <p:sp>
+        <p:nvSpPr>
+          <p:cNvPr id="16" name="TextBox 15"/>
+          <p:cNvSpPr txBox="1"/>
+          <p:nvPr/>
+        </p:nvSpPr>
+        <p:spPr>
+          <a:xfrm>
+            <a:off x="8439911" y="1069848"/>
+            <a:ext cx="3474720" cy="475488"/>
+          </a:xfrm>
+          <a:prstGeom prst="rect">
+            <a:avLst/>
+          </a:prstGeom>
+          <a:noFill/>
+        </p:spPr>
+        <p:txBody>
+          <a:bodyPr wrap="square">
+            <a:spAutoFit/>
+          </a:bodyPr>
+          <a:lstStyle/>
+          <a:p>
+            <a:pPr algn="l"/>
+            <a:r>
+              <a:rPr sz="1500" b="1" i="0">
+                <a:solidFill>
+                  <a:srgbClr val="FFFFFF"/>
+                </a:solidFill>
+              </a:rPr>
+              <a:t>✨  Zero User Friction</a:t>
+            </a:r>
+          </a:p>
+        </p:txBody>
+      </p:sp>
+      <p:sp>
+        <p:nvSpPr>
+          <p:cNvPr id="17" name="TextBox 16"/>
+          <p:cNvSpPr txBox="1"/>
+          <p:nvPr/>
+        </p:nvSpPr>
+        <p:spPr>
+          <a:xfrm>
+            <a:off x="8439911" y="1691640"/>
+            <a:ext cx="3456432" cy="4297680"/>
+          </a:xfrm>
+          <a:prstGeom prst="rect">
+            <a:avLst/>
+          </a:prstGeom>
+          <a:noFill/>
+        </p:spPr>
+        <p:txBody>
+          <a:bodyPr wrap="square">
+            <a:spAutoFit/>
+          </a:bodyPr>
+          <a:lstStyle/>
+          <a:p>
+            <a:pPr algn="l"/>
+            <a:r>
+              <a:rPr sz="1300" b="0" i="0">
+                <a:solidFill>
+                  <a:srgbClr val="FFFFFF"/>
+                </a:solidFill>
+              </a:rPr>
+              <a:t>Both security measures happen in milliseconds behind the scenes.
+Legitimate users attempting to log in normally will not even notice they are there — no extra steps, no delays, no CAPTCHA.</a:t>
+            </a:r>
+          </a:p>
+        </p:txBody>
+      </p:sp>
+      <p:sp>
+        <p:nvSpPr>
+          <p:cNvPr id="18" name="Rectangle 17"/>
+          <p:cNvSpPr/>
+          <p:nvPr/>
+        </p:nvSpPr>
+        <p:spPr>
+          <a:xfrm>
+            <a:off x="0" y="6537960"/>
+            <a:ext cx="12188952" cy="320040"/>
+          </a:xfrm>
+          <a:prstGeom prst="rect">
+            <a:avLst/>
+          </a:prstGeom>
+          <a:solidFill>
+            <a:srgbClr val="0F3D6E"/>
+          </a:solidFill>
+          <a:ln>
+            <a:noFill/>
+          </a:ln>
+        </p:spPr>
+        <p:style>
+          <a:lnRef idx="1">
+            <a:schemeClr val="accent1"/>
+          </a:lnRef>
+          <a:fillRef idx="3">
+            <a:schemeClr val="accent1"/>
+          </a:fillRef>
+          <a:effectRef idx="2">
+            <a:schemeClr val="accent1"/>
+          </a:effectRef>
+          <a:fontRef idx="minor">
+            <a:schemeClr val="lt1"/>
+          </a:fontRef>
+        </p:style>
+        <p:txBody>
+          <a:bodyPr rtlCol="0" anchor="ctr"/>
+          <a:lstStyle/>
+          <a:p>
+            <a:pPr algn="ctr"/>
+          </a:p>
+        </p:txBody>
+      </p:sp>
+      <p:sp>
+        <p:nvSpPr>
+          <p:cNvPr id="19" name="TextBox 18"/>
+          <p:cNvSpPr txBox="1"/>
+          <p:nvPr/>
+        </p:nvSpPr>
+        <p:spPr>
+          <a:xfrm>
+            <a:off x="274320" y="6565392"/>
+            <a:ext cx="11887200" cy="256032"/>
+          </a:xfrm>
+          <a:prstGeom prst="rect">
+            <a:avLst/>
+          </a:prstGeom>
+          <a:noFill/>
+        </p:spPr>
+        <p:txBody>
+          <a:bodyPr wrap="square">
+            <a:spAutoFit/>
+          </a:bodyPr>
+          <a:lstStyle/>
+          <a:p>
+            <a:pPr algn="l"/>
+            <a:r>
+              <a:rPr sz="900" b="0" i="0">
+                <a:solidFill>
+                  <a:srgbClr val="CCCCCC"/>
+                </a:solidFill>
+              </a:rPr>
+              <a:t>SMS Pumping Defence  |  Confidential</a:t>
+            </a:r>
+          </a:p>
+        </p:txBody>
+      </p:sp>
+    </p:spTree>
+  </p:cSld>
+  <p:clrMapOvr>
+    <a:masterClrMapping/>
+  </p:clrMapOvr>
+</p:sld>
+</file>
+
+<file path=ppt/slides/slide6.xml><?xml version="1.0" encoding="utf-8"?>
+<p:sld xmlns:a="http://schemas.openxmlformats.org/drawingml/2006/main" xmlns:p="http://schemas.openxmlformats.org/presentationml/2006/main" xmlns:r="http://schemas.openxmlformats.org/officeDocument/2006/relationships">
+  <p:cSld>
+    <p:bg>
+      <p:bgPr>
+        <a:solidFill>
+          <a:srgbClr val="1A1A2E"/>
+        </a:solidFill>
+        <a:effectLst/>
+      </p:bgPr>
+    </p:bg>
+    <p:spTree>
+      <p:nvGrpSpPr>
+        <p:cNvPr id="1" name=""/>
+        <p:cNvGrpSpPr/>
+        <p:nvPr/>
+      </p:nvGrpSpPr>
+      <p:grpSpPr/>
+      <p:sp>
+        <p:nvSpPr>
+          <p:cNvPr id="2" name="Rectangle 1"/>
+          <p:cNvSpPr/>
+          <p:nvPr/>
+        </p:nvSpPr>
+        <p:spPr>
+          <a:xfrm>
+            <a:off x="0" y="0"/>
+            <a:ext cx="12188952" cy="685800"/>
+          </a:xfrm>
+          <a:prstGeom prst="rect">
+            <a:avLst/>
+          </a:prstGeom>
+          <a:solidFill>
+            <a:srgbClr val="0F3D6E"/>
+          </a:solidFill>
+          <a:ln>
+            <a:noFill/>
+          </a:ln>
+        </p:spPr>
+        <p:style>
+          <a:lnRef idx="1">
+            <a:schemeClr val="accent1"/>
+          </a:lnRef>
+          <a:fillRef idx="3">
+            <a:schemeClr val="accent1"/>
+          </a:fillRef>
+          <a:effectRef idx="2">
+            <a:schemeClr val="accent1"/>
+          </a:effectRef>
+          <a:fontRef idx="minor">
+            <a:schemeClr val="lt1"/>
+          </a:fontRef>
+        </p:style>
+        <p:txBody>
+          <a:bodyPr rtlCol="0" anchor="ctr"/>
+          <a:lstStyle/>
+          <a:p>
+            <a:pPr algn="ctr"/>
+          </a:p>
+        </p:txBody>
+      </p:sp>
+      <p:sp>
+        <p:nvSpPr>
+          <p:cNvPr id="3" name="TextBox 2"/>
+          <p:cNvSpPr txBox="1"/>
+          <p:nvPr/>
+        </p:nvSpPr>
+        <p:spPr>
+          <a:xfrm>
+            <a:off x="182880" y="73152"/>
+            <a:ext cx="2743200" cy="457200"/>
+          </a:xfrm>
+          <a:prstGeom prst="rect">
+            <a:avLst/>
+          </a:prstGeom>
+          <a:noFill/>
+        </p:spPr>
+        <p:txBody>
+          <a:bodyPr wrap="square">
+            <a:spAutoFit/>
+          </a:bodyPr>
+          <a:lstStyle/>
+          <a:p>
+            <a:pPr algn="l"/>
+            <a:r>
+              <a:rPr sz="1000" b="0" i="0">
+                <a:solidFill>
+                  <a:srgbClr val="CCCCCC"/>
+                </a:solidFill>
+              </a:rPr>
+              <a:t>Slide 6 of 6</a:t>
+            </a:r>
+          </a:p>
+        </p:txBody>
+      </p:sp>
+      <p:sp>
+        <p:nvSpPr>
+          <p:cNvPr id="4" name="TextBox 3"/>
+          <p:cNvSpPr txBox="1"/>
+          <p:nvPr/>
+        </p:nvSpPr>
+        <p:spPr>
+          <a:xfrm>
+            <a:off x="274320" y="45720"/>
+            <a:ext cx="11430000" cy="640080"/>
+          </a:xfrm>
+          <a:prstGeom prst="rect">
+            <a:avLst/>
+          </a:prstGeom>
+          <a:noFill/>
+        </p:spPr>
+        <p:txBody>
+          <a:bodyPr wrap="square">
+            <a:spAutoFit/>
+          </a:bodyPr>
+          <a:lstStyle/>
+          <a:p>
+            <a:pPr algn="l"/>
+            <a:r>
+              <a:rPr sz="2600" b="1" i="0">
+                <a:solidFill>
+                  <a:srgbClr val="FFFFFF"/>
+                </a:solidFill>
+              </a:rPr>
+              <a:t>How Our Defence Works – At a Glance</a:t>
+            </a:r>
+          </a:p>
+        </p:txBody>
+      </p:sp>
+      <p:sp>
+        <p:nvSpPr>
+          <p:cNvPr id="5" name="Rectangle 4"/>
+          <p:cNvSpPr/>
+          <p:nvPr/>
+        </p:nvSpPr>
+        <p:spPr>
+          <a:xfrm>
+            <a:off x="0" y="658368"/>
+            <a:ext cx="12188952" cy="54864"/>
+          </a:xfrm>
+          <a:prstGeom prst="rect">
+            <a:avLst/>
+          </a:prstGeom>
+          <a:solidFill>
+            <a:srgbClr val="E94F37"/>
+          </a:solidFill>
+          <a:ln>
+            <a:noFill/>
+          </a:ln>
+        </p:spPr>
+        <p:style>
+          <a:lnRef idx="1">
+            <a:schemeClr val="accent1"/>
+          </a:lnRef>
+          <a:fillRef idx="3">
+            <a:schemeClr val="accent1"/>
+          </a:fillRef>
+          <a:effectRef idx="2">
+            <a:schemeClr val="accent1"/>
+          </a:effectRef>
+          <a:fontRef idx="minor">
+            <a:schemeClr val="lt1"/>
+          </a:fontRef>
+        </p:style>
+        <p:txBody>
+          <a:bodyPr rtlCol="0" anchor="ctr"/>
+          <a:lstStyle/>
+          <a:p>
+            <a:pPr algn="ctr"/>
+          </a:p>
+        </p:txBody>
+      </p:sp>
+      <p:sp>
+        <p:nvSpPr>
+          <p:cNvPr id="6" name="TextBox 5"/>
+          <p:cNvSpPr txBox="1"/>
+          <p:nvPr/>
+        </p:nvSpPr>
+        <p:spPr>
+          <a:xfrm>
+            <a:off x="457200" y="777240"/>
+            <a:ext cx="11247120" cy="502920"/>
+          </a:xfrm>
+          <a:prstGeom prst="rect">
+            <a:avLst/>
+          </a:prstGeom>
+          <a:noFill/>
+        </p:spPr>
+        <p:txBody>
+          <a:bodyPr wrap="square">
+            <a:spAutoFit/>
+          </a:bodyPr>
+          <a:lstStyle/>
+          <a:p>
+            <a:pPr algn="ctr"/>
+            <a:r>
+              <a:rPr sz="1400" b="0" i="0">
+                <a:solidFill>
+                  <a:srgbClr val="CCCCCC"/>
+                </a:solidFill>
+              </a:rPr>
+              <a:t>Every SMS request passes through two automatic checkpoints before we are charged a penny.</a:t>
+            </a:r>
+          </a:p>
+        </p:txBody>
+      </p:sp>
+      <p:sp>
+        <p:nvSpPr>
+          <p:cNvPr id="7" name="Rectangle 6"/>
+          <p:cNvSpPr/>
+          <p:nvPr/>
+        </p:nvSpPr>
+        <p:spPr>
+          <a:xfrm>
+            <a:off x="228600" y="1508760"/>
+            <a:ext cx="2331720" cy="1005840"/>
+          </a:xfrm>
+          <a:prstGeom prst="rect">
+            <a:avLst/>
+          </a:prstGeom>
+          <a:solidFill>
+            <a:srgbClr val="0F3D6E"/>
+          </a:solidFill>
+          <a:ln w="25400">
+            <a:solidFill>
+              <a:srgbClr val="E94F37"/>
+            </a:solidFill>
+          </a:ln>
+        </p:spPr>
+        <p:style>
+          <a:lnRef idx="1">
+            <a:schemeClr val="accent1"/>
+          </a:lnRef>
+          <a:fillRef idx="3">
+            <a:schemeClr val="accent1"/>
+          </a:fillRef>
+          <a:effectRef idx="2">
+            <a:schemeClr val="accent1"/>
+          </a:effectRef>
+          <a:fontRef idx="minor">
+            <a:schemeClr val="lt1"/>
+          </a:fontRef>
+        </p:style>
+        <p:txBody>
+          <a:bodyPr rtlCol="0" anchor="ctr"/>
+          <a:lstStyle/>
+          <a:p>
+            <a:pPr algn="ctr"/>
+          </a:p>
+        </p:txBody>
+      </p:sp>
+      <p:sp>
+        <p:nvSpPr>
+          <p:cNvPr id="8" name="TextBox 7"/>
+          <p:cNvSpPr txBox="1"/>
+          <p:nvPr/>
+        </p:nvSpPr>
+        <p:spPr>
+          <a:xfrm>
+            <a:off x="338328" y="1581912"/>
+            <a:ext cx="2112263" cy="475488"/>
+          </a:xfrm>
+          <a:prstGeom prst="rect">
+            <a:avLst/>
+          </a:prstGeom>
+          <a:noFill/>
+        </p:spPr>
+        <p:txBody>
+          <a:bodyPr wrap="square">
+            <a:spAutoFit/>
+          </a:bodyPr>
+          <a:lstStyle/>
+          <a:p>
+            <a:pPr algn="ctr"/>
+            <a:r>
+              <a:rPr sz="1300" b="1" i="0">
+                <a:solidFill>
+                  <a:srgbClr val="FFFFFF"/>
+                </a:solidFill>
+              </a:rPr>
+              <a:t>📲  SMS Request</a:t>
+            </a:r>
+          </a:p>
+        </p:txBody>
+      </p:sp>
+      <p:sp>
+        <p:nvSpPr>
+          <p:cNvPr id="9" name="TextBox 8"/>
+          <p:cNvSpPr txBox="1"/>
+          <p:nvPr/>
+        </p:nvSpPr>
+        <p:spPr>
+          <a:xfrm>
+            <a:off x="320040" y="2011680"/>
+            <a:ext cx="2148839" cy="457200"/>
+          </a:xfrm>
+          <a:prstGeom prst="rect">
+            <a:avLst/>
+          </a:prstGeom>
+          <a:noFill/>
+        </p:spPr>
+        <p:txBody>
+          <a:bodyPr wrap="square">
+            <a:spAutoFit/>
+          </a:bodyPr>
+          <a:lstStyle/>
+          <a:p>
+            <a:pPr algn="ctr"/>
+            <a:r>
+              <a:rPr sz="1000" b="0" i="0">
+                <a:solidFill>
+                  <a:srgbClr val="CCCCCC"/>
+                </a:solidFill>
+              </a:rPr>
+              <a:t>User taps 'Send Code'</a:t>
+            </a:r>
+          </a:p>
+        </p:txBody>
+      </p:sp>
+      <p:sp>
+        <p:nvSpPr>
+          <p:cNvPr id="10" name="TextBox 9"/>
+          <p:cNvSpPr txBox="1"/>
+          <p:nvPr/>
+        </p:nvSpPr>
+        <p:spPr>
+          <a:xfrm>
+            <a:off x="2606039" y="1801368"/>
+            <a:ext cx="502920" cy="411480"/>
+          </a:xfrm>
+          <a:prstGeom prst="rect">
+            <a:avLst/>
+          </a:prstGeom>
+          <a:noFill/>
+        </p:spPr>
+        <p:txBody>
+          <a:bodyPr wrap="square">
+            <a:spAutoFit/>
+          </a:bodyPr>
+          <a:lstStyle/>
+          <a:p>
+            <a:pPr algn="ctr"/>
+            <a:r>
+              <a:rPr sz="2000" b="0" i="0">
+                <a:solidFill>
+                  <a:srgbClr val="E94F37"/>
+                </a:solidFill>
+              </a:rPr>
+              <a:t>➤</a:t>
+            </a:r>
+          </a:p>
+        </p:txBody>
+      </p:sp>
+      <p:sp>
+        <p:nvSpPr>
+          <p:cNvPr id="11" name="Rectangle 10"/>
+          <p:cNvSpPr/>
+          <p:nvPr/>
+        </p:nvSpPr>
+        <p:spPr>
+          <a:xfrm>
+            <a:off x="2834640" y="1508760"/>
+            <a:ext cx="2331720" cy="1005840"/>
+          </a:xfrm>
+          <a:prstGeom prst="rect">
+            <a:avLst/>
+          </a:prstGeom>
+          <a:solidFill>
+            <a:srgbClr val="14508A"/>
+          </a:solidFill>
+          <a:ln w="25400">
+            <a:solidFill>
+              <a:srgbClr val="E94F37"/>
+            </a:solidFill>
+          </a:ln>
+        </p:spPr>
+        <p:style>
+          <a:lnRef idx="1">
+            <a:schemeClr val="accent1"/>
+          </a:lnRef>
+          <a:fillRef idx="3">
+            <a:schemeClr val="accent1"/>
+          </a:fillRef>
+          <a:effectRef idx="2">
+            <a:schemeClr val="accent1"/>
+          </a:effectRef>
+          <a:fontRef idx="minor">
+            <a:schemeClr val="lt1"/>
+          </a:fontRef>
+        </p:style>
+        <p:txBody>
+          <a:bodyPr rtlCol="0" anchor="ctr"/>
+          <a:lstStyle/>
+          <a:p>
+            <a:pPr algn="ctr"/>
+          </a:p>
+        </p:txBody>
+      </p:sp>
+      <p:sp>
+        <p:nvSpPr>
+          <p:cNvPr id="12" name="TextBox 11"/>
+          <p:cNvSpPr txBox="1"/>
+          <p:nvPr/>
+        </p:nvSpPr>
+        <p:spPr>
+          <a:xfrm>
+            <a:off x="2944368" y="1581912"/>
+            <a:ext cx="2112263" cy="475488"/>
+          </a:xfrm>
+          <a:prstGeom prst="rect">
+            <a:avLst/>
+          </a:prstGeom>
+          <a:noFill/>
+        </p:spPr>
+        <p:txBody>
+          <a:bodyPr wrap="square">
+            <a:spAutoFit/>
+          </a:bodyPr>
+          <a:lstStyle/>
+          <a:p>
+            <a:pPr algn="ctr"/>
+            <a:r>
+              <a:rPr sz="1300" b="1" i="0">
+                <a:solidFill>
+                  <a:srgbClr val="FFFFFF"/>
+                </a:solidFill>
+              </a:rPr>
+              <a:t>🛡️  Checkpoint 1</a:t>
+            </a:r>
+          </a:p>
+        </p:txBody>
+      </p:sp>
+      <p:sp>
+        <p:nvSpPr>
+          <p:cNvPr id="13" name="TextBox 12"/>
+          <p:cNvSpPr txBox="1"/>
+          <p:nvPr/>
+        </p:nvSpPr>
+        <p:spPr>
+          <a:xfrm>
+            <a:off x="2926080" y="2011680"/>
+            <a:ext cx="2148839" cy="457200"/>
+          </a:xfrm>
+          <a:prstGeom prst="rect">
+            <a:avLst/>
+          </a:prstGeom>
+          <a:noFill/>
+        </p:spPr>
+        <p:txBody>
+          <a:bodyPr wrap="square">
+            <a:spAutoFit/>
+          </a:bodyPr>
+          <a:lstStyle/>
+          <a:p>
+            <a:pPr algn="ctr"/>
+            <a:r>
+              <a:rPr sz="1000" b="0" i="0">
+                <a:solidFill>
+                  <a:srgbClr val="CCCCCC"/>
+                </a:solidFill>
+              </a:rPr>
+              <a:t>Is this our real app?</a:t>
+            </a:r>
+          </a:p>
+        </p:txBody>
+      </p:sp>
+      <p:sp>
+        <p:nvSpPr>
+          <p:cNvPr id="14" name="TextBox 13"/>
+          <p:cNvSpPr txBox="1"/>
+          <p:nvPr/>
+        </p:nvSpPr>
+        <p:spPr>
+          <a:xfrm>
+            <a:off x="5212080" y="1801368"/>
+            <a:ext cx="502920" cy="411480"/>
+          </a:xfrm>
+          <a:prstGeom prst="rect">
+            <a:avLst/>
+          </a:prstGeom>
+          <a:noFill/>
+        </p:spPr>
+        <p:txBody>
+          <a:bodyPr wrap="square">
+            <a:spAutoFit/>
+          </a:bodyPr>
+          <a:lstStyle/>
+          <a:p>
+            <a:pPr algn="ctr"/>
+            <a:r>
+              <a:rPr sz="2000" b="0" i="0">
+                <a:solidFill>
+                  <a:srgbClr val="E94F37"/>
+                </a:solidFill>
+              </a:rPr>
+              <a:t>➤</a:t>
+            </a:r>
+          </a:p>
+        </p:txBody>
+      </p:sp>
+      <p:sp>
+        <p:nvSpPr>
+          <p:cNvPr id="15" name="Rectangle 14"/>
+          <p:cNvSpPr/>
+          <p:nvPr/>
+        </p:nvSpPr>
+        <p:spPr>
+          <a:xfrm>
+            <a:off x="5989320" y="1508760"/>
+            <a:ext cx="2331720" cy="1005840"/>
+          </a:xfrm>
+          <a:prstGeom prst="rect">
+            <a:avLst/>
+          </a:prstGeom>
+          <a:solidFill>
+            <a:srgbClr val="14508A"/>
+          </a:solidFill>
+          <a:ln w="25400">
+            <a:solidFill>
+              <a:srgbClr val="E94F37"/>
+            </a:solidFill>
+          </a:ln>
+        </p:spPr>
+        <p:style>
+          <a:lnRef idx="1">
+            <a:schemeClr val="accent1"/>
+          </a:lnRef>
+          <a:fillRef idx="3">
+            <a:schemeClr val="accent1"/>
+          </a:fillRef>
+          <a:effectRef idx="2">
+            <a:schemeClr val="accent1"/>
+          </a:effectRef>
+          <a:fontRef idx="minor">
+            <a:schemeClr val="lt1"/>
+          </a:fontRef>
+        </p:style>
+        <p:txBody>
+          <a:bodyPr rtlCol="0" anchor="ctr"/>
+          <a:lstStyle/>
+          <a:p>
+            <a:pPr algn="ctr"/>
+          </a:p>
+        </p:txBody>
+      </p:sp>
+      <p:sp>
+        <p:nvSpPr>
+          <p:cNvPr id="16" name="TextBox 15"/>
+          <p:cNvSpPr txBox="1"/>
+          <p:nvPr/>
+        </p:nvSpPr>
+        <p:spPr>
+          <a:xfrm>
+            <a:off x="6099048" y="1581912"/>
+            <a:ext cx="2112263" cy="475488"/>
+          </a:xfrm>
+          <a:prstGeom prst="rect">
+            <a:avLst/>
+          </a:prstGeom>
+          <a:noFill/>
+        </p:spPr>
+        <p:txBody>
+          <a:bodyPr wrap="square">
+            <a:spAutoFit/>
+          </a:bodyPr>
+          <a:lstStyle/>
+          <a:p>
+            <a:pPr algn="ctr"/>
+            <a:r>
+              <a:rPr sz="1300" b="1" i="0">
+                <a:solidFill>
+                  <a:srgbClr val="FFFFFF"/>
+                </a:solidFill>
+              </a:rPr>
+              <a:t>⏱️  Checkpoint 2</a:t>
+            </a:r>
+          </a:p>
+        </p:txBody>
+      </p:sp>
+      <p:sp>
+        <p:nvSpPr>
+          <p:cNvPr id="17" name="TextBox 16"/>
+          <p:cNvSpPr txBox="1"/>
+          <p:nvPr/>
+        </p:nvSpPr>
+        <p:spPr>
+          <a:xfrm>
+            <a:off x="6080759" y="2011680"/>
+            <a:ext cx="2148839" cy="457200"/>
+          </a:xfrm>
+          <a:prstGeom prst="rect">
+            <a:avLst/>
+          </a:prstGeom>
+          <a:noFill/>
+        </p:spPr>
+        <p:txBody>
+          <a:bodyPr wrap="square">
+            <a:spAutoFit/>
+          </a:bodyPr>
+          <a:lstStyle/>
+          <a:p>
+            <a:pPr algn="ctr"/>
+            <a:r>
+              <a:rPr sz="1000" b="0" i="0">
+                <a:solidFill>
+                  <a:srgbClr val="CCCCCC"/>
+                </a:solidFill>
+              </a:rPr>
+              <a:t>Is the request rate normal?</a:t>
+            </a:r>
+          </a:p>
+        </p:txBody>
+      </p:sp>
+      <p:sp>
+        <p:nvSpPr>
+          <p:cNvPr id="18" name="TextBox 17"/>
+          <p:cNvSpPr txBox="1"/>
+          <p:nvPr/>
+        </p:nvSpPr>
+        <p:spPr>
+          <a:xfrm>
+            <a:off x="8366760" y="1801368"/>
+            <a:ext cx="502920" cy="411480"/>
+          </a:xfrm>
+          <a:prstGeom prst="rect">
+            <a:avLst/>
+          </a:prstGeom>
+          <a:noFill/>
+        </p:spPr>
+        <p:txBody>
+          <a:bodyPr wrap="square">
+            <a:spAutoFit/>
+          </a:bodyPr>
+          <a:lstStyle/>
+          <a:p>
+            <a:pPr algn="ctr"/>
+            <a:r>
+              <a:rPr sz="2000" b="0" i="0">
+                <a:solidFill>
+                  <a:srgbClr val="E94F37"/>
+                </a:solidFill>
+              </a:rPr>
+              <a:t>➤</a:t>
+            </a:r>
+          </a:p>
+        </p:txBody>
+      </p:sp>
+      <p:sp>
+        <p:nvSpPr>
+          <p:cNvPr id="19" name="Rectangle 18"/>
+          <p:cNvSpPr/>
+          <p:nvPr/>
+        </p:nvSpPr>
+        <p:spPr>
+          <a:xfrm>
+            <a:off x="9326880" y="1508760"/>
+            <a:ext cx="2331720" cy="1005840"/>
+          </a:xfrm>
+          <a:prstGeom prst="rect">
+            <a:avLst/>
+          </a:prstGeom>
+          <a:solidFill>
+            <a:srgbClr val="00AA55"/>
+          </a:solidFill>
+          <a:ln w="25400">
+            <a:solidFill>
+              <a:srgbClr val="00FF88"/>
+            </a:solidFill>
+          </a:ln>
+        </p:spPr>
+        <p:style>
+          <a:lnRef idx="1">
+            <a:schemeClr val="accent1"/>
+          </a:lnRef>
+          <a:fillRef idx="3">
+            <a:schemeClr val="accent1"/>
+          </a:fillRef>
+          <a:effectRef idx="2">
+            <a:schemeClr val="accent1"/>
+          </a:effectRef>
+          <a:fontRef idx="minor">
+            <a:schemeClr val="lt1"/>
+          </a:fontRef>
+        </p:style>
+        <p:txBody>
+          <a:bodyPr rtlCol="0" anchor="ctr"/>
+          <a:lstStyle/>
+          <a:p>
+            <a:pPr algn="ctr"/>
+          </a:p>
+        </p:txBody>
+      </p:sp>
+      <p:sp>
+        <p:nvSpPr>
+          <p:cNvPr id="20" name="TextBox 19"/>
+          <p:cNvSpPr txBox="1"/>
+          <p:nvPr/>
+        </p:nvSpPr>
+        <p:spPr>
+          <a:xfrm>
+            <a:off x="9436607" y="1581912"/>
+            <a:ext cx="2112263" cy="475488"/>
+          </a:xfrm>
+          <a:prstGeom prst="rect">
+            <a:avLst/>
+          </a:prstGeom>
+          <a:noFill/>
+        </p:spPr>
+        <p:txBody>
+          <a:bodyPr wrap="square">
+            <a:spAutoFit/>
+          </a:bodyPr>
+          <a:lstStyle/>
+          <a:p>
+            <a:pPr algn="ctr"/>
+            <a:r>
+              <a:rPr sz="1300" b="1" i="0">
+                <a:solidFill>
+                  <a:srgbClr val="FFFFFF"/>
+                </a:solidFill>
+              </a:rPr>
+              <a:t>✅  SMS Sent!</a:t>
+            </a:r>
+          </a:p>
+        </p:txBody>
+      </p:sp>
+      <p:sp>
+        <p:nvSpPr>
+          <p:cNvPr id="21" name="TextBox 20"/>
+          <p:cNvSpPr txBox="1"/>
+          <p:nvPr/>
+        </p:nvSpPr>
+        <p:spPr>
+          <a:xfrm>
+            <a:off x="9418319" y="2011680"/>
+            <a:ext cx="2148839" cy="457200"/>
+          </a:xfrm>
+          <a:prstGeom prst="rect">
+            <a:avLst/>
+          </a:prstGeom>
+          <a:noFill/>
+        </p:spPr>
+        <p:txBody>
+          <a:bodyPr wrap="square">
+            <a:spAutoFit/>
+          </a:bodyPr>
+          <a:lstStyle/>
+          <a:p>
+            <a:pPr algn="ctr"/>
+            <a:r>
+              <a:rPr sz="1000" b="0" i="0">
+                <a:solidFill>
+                  <a:srgbClr val="CCFFCC"/>
+                </a:solidFill>
+              </a:rPr>
+              <a:t>Twilio charged — legitimate user</a:t>
+            </a:r>
+          </a:p>
+        </p:txBody>
+      </p:sp>
+      <p:sp>
+        <p:nvSpPr>
+          <p:cNvPr id="22" name="TextBox 21"/>
+          <p:cNvSpPr txBox="1"/>
+          <p:nvPr/>
+        </p:nvSpPr>
+        <p:spPr>
+          <a:xfrm>
+            <a:off x="3954780" y="2560320"/>
+            <a:ext cx="411480" cy="347472"/>
+          </a:xfrm>
+          <a:prstGeom prst="rect">
+            <a:avLst/>
+          </a:prstGeom>
+          <a:noFill/>
+        </p:spPr>
+        <p:txBody>
+          <a:bodyPr wrap="square">
+            <a:spAutoFit/>
+          </a:bodyPr>
+          <a:lstStyle/>
+          <a:p>
+            <a:pPr algn="ctr"/>
+            <a:r>
+              <a:rPr sz="1600" b="0" i="0">
+                <a:solidFill>
+                  <a:srgbClr val="FF4444"/>
+                </a:solidFill>
+              </a:rPr>
+              <a:t>▼</a:t>
+            </a:r>
+          </a:p>
+        </p:txBody>
+      </p:sp>
+      <p:sp>
+        <p:nvSpPr>
+          <p:cNvPr id="23" name="TextBox 22"/>
+          <p:cNvSpPr txBox="1"/>
+          <p:nvPr/>
+        </p:nvSpPr>
+        <p:spPr>
+          <a:xfrm>
+            <a:off x="7109459" y="2560320"/>
+            <a:ext cx="411480" cy="347472"/>
+          </a:xfrm>
+          <a:prstGeom prst="rect">
+            <a:avLst/>
+          </a:prstGeom>
+          <a:noFill/>
+        </p:spPr>
+        <p:txBody>
+          <a:bodyPr wrap="square">
+            <a:spAutoFit/>
+          </a:bodyPr>
+          <a:lstStyle/>
+          <a:p>
+            <a:pPr algn="ctr"/>
+            <a:r>
+              <a:rPr sz="1600" b="0" i="0">
+                <a:solidFill>
+                  <a:srgbClr val="FF4444"/>
+                </a:solidFill>
+              </a:rPr>
+              <a:t>▼</a:t>
+            </a:r>
+          </a:p>
+        </p:txBody>
+      </p:sp>
+      <p:sp>
+        <p:nvSpPr>
+          <p:cNvPr id="24" name="Rectangle 23"/>
+          <p:cNvSpPr/>
+          <p:nvPr/>
+        </p:nvSpPr>
+        <p:spPr>
+          <a:xfrm>
+            <a:off x="2651760" y="3063240"/>
+            <a:ext cx="2743200" cy="1417320"/>
+          </a:xfrm>
+          <a:prstGeom prst="rect">
+            <a:avLst/>
+          </a:prstGeom>
+          <a:solidFill>
+            <a:srgbClr val="6B0000"/>
+          </a:solidFill>
+          <a:ln w="25400">
+            <a:solidFill>
+              <a:srgbClr val="FF4444"/>
+            </a:solidFill>
+          </a:ln>
+        </p:spPr>
+        <p:style>
+          <a:lnRef idx="1">
+            <a:schemeClr val="accent1"/>
+          </a:lnRef>
+          <a:fillRef idx="3">
+            <a:schemeClr val="accent1"/>
+          </a:fillRef>
+          <a:effectRef idx="2">
+            <a:schemeClr val="accent1"/>
+          </a:effectRef>
+          <a:fontRef idx="minor">
+            <a:schemeClr val="lt1"/>
+          </a:fontRef>
+        </p:style>
+        <p:txBody>
+          <a:bodyPr rtlCol="0" anchor="ctr"/>
+          <a:lstStyle/>
+          <a:p>
+            <a:pPr algn="ctr"/>
+          </a:p>
+        </p:txBody>
+      </p:sp>
+      <p:sp>
+        <p:nvSpPr>
+          <p:cNvPr id="25" name="TextBox 24"/>
+          <p:cNvSpPr txBox="1"/>
+          <p:nvPr/>
+        </p:nvSpPr>
+        <p:spPr>
+          <a:xfrm>
+            <a:off x="2761488" y="3127248"/>
+            <a:ext cx="2523744" cy="384048"/>
+          </a:xfrm>
+          <a:prstGeom prst="rect">
+            <a:avLst/>
+          </a:prstGeom>
+          <a:noFill/>
+        </p:spPr>
+        <p:txBody>
+          <a:bodyPr wrap="square">
+            <a:spAutoFit/>
+          </a:bodyPr>
+          <a:lstStyle/>
+          <a:p>
+            <a:pPr algn="ctr"/>
+            <a:r>
+              <a:rPr sz="1300" b="1" i="0">
+                <a:solidFill>
+                  <a:srgbClr val="FF4444"/>
+                </a:solidFill>
+              </a:rPr>
+              <a:t>❌  Blocked — FREE</a:t>
+            </a:r>
+          </a:p>
+        </p:txBody>
+      </p:sp>
+      <p:sp>
+        <p:nvSpPr>
+          <p:cNvPr id="26" name="TextBox 25"/>
+          <p:cNvSpPr txBox="1"/>
+          <p:nvPr/>
+        </p:nvSpPr>
+        <p:spPr>
+          <a:xfrm>
+            <a:off x="2761488" y="3502152"/>
+            <a:ext cx="2523744" cy="914400"/>
+          </a:xfrm>
+          <a:prstGeom prst="rect">
+            <a:avLst/>
+          </a:prstGeom>
+          <a:noFill/>
+        </p:spPr>
+        <p:txBody>
+          <a:bodyPr wrap="square">
+            <a:spAutoFit/>
+          </a:bodyPr>
+          <a:lstStyle/>
+          <a:p>
+            <a:pPr algn="ctr"/>
+            <a:r>
+              <a:rPr sz="1100" b="0" i="0">
+                <a:solidFill>
+                  <a:srgbClr val="CCCCCC"/>
+                </a:solidFill>
+              </a:rPr>
+              <a:t>Bot / script without
+a valid app token.
+Cost to us: $0</a:t>
+            </a:r>
+          </a:p>
+        </p:txBody>
+      </p:sp>
+      <p:sp>
+        <p:nvSpPr>
+          <p:cNvPr id="27" name="Rectangle 26"/>
+          <p:cNvSpPr/>
+          <p:nvPr/>
+        </p:nvSpPr>
+        <p:spPr>
+          <a:xfrm>
+            <a:off x="5806440" y="3063240"/>
+            <a:ext cx="2743200" cy="1417320"/>
+          </a:xfrm>
+          <a:prstGeom prst="rect">
+            <a:avLst/>
+          </a:prstGeom>
+          <a:solidFill>
+            <a:srgbClr val="6B0000"/>
+          </a:solidFill>
+          <a:ln w="25400">
+            <a:solidFill>
+              <a:srgbClr val="FF4444"/>
+            </a:solidFill>
+          </a:ln>
+        </p:spPr>
+        <p:style>
+          <a:lnRef idx="1">
+            <a:schemeClr val="accent1"/>
+          </a:lnRef>
+          <a:fillRef idx="3">
+            <a:schemeClr val="accent1"/>
+          </a:fillRef>
+          <a:effectRef idx="2">
+            <a:schemeClr val="accent1"/>
+          </a:effectRef>
+          <a:fontRef idx="minor">
+            <a:schemeClr val="lt1"/>
+          </a:fontRef>
+        </p:style>
+        <p:txBody>
+          <a:bodyPr rtlCol="0" anchor="ctr"/>
+          <a:lstStyle/>
+          <a:p>
+            <a:pPr algn="ctr"/>
+          </a:p>
+        </p:txBody>
+      </p:sp>
+      <p:sp>
+        <p:nvSpPr>
+          <p:cNvPr id="28" name="TextBox 27"/>
+          <p:cNvSpPr txBox="1"/>
+          <p:nvPr/>
+        </p:nvSpPr>
+        <p:spPr>
+          <a:xfrm>
+            <a:off x="5916168" y="3127248"/>
+            <a:ext cx="2523744" cy="384048"/>
+          </a:xfrm>
+          <a:prstGeom prst="rect">
+            <a:avLst/>
+          </a:prstGeom>
+          <a:noFill/>
+        </p:spPr>
+        <p:txBody>
+          <a:bodyPr wrap="square">
+            <a:spAutoFit/>
+          </a:bodyPr>
+          <a:lstStyle/>
+          <a:p>
+            <a:pPr algn="ctr"/>
+            <a:r>
+              <a:rPr sz="1300" b="1" i="0">
+                <a:solidFill>
+                  <a:srgbClr val="FFD700"/>
+                </a:solidFill>
+              </a:rPr>
+              <a:t>⚠️  Throttled — FREE</a:t>
+            </a:r>
+          </a:p>
+        </p:txBody>
+      </p:sp>
+      <p:sp>
+        <p:nvSpPr>
+          <p:cNvPr id="29" name="TextBox 28"/>
+          <p:cNvSpPr txBox="1"/>
+          <p:nvPr/>
+        </p:nvSpPr>
+        <p:spPr>
+          <a:xfrm>
+            <a:off x="5916168" y="3502152"/>
+            <a:ext cx="2523744" cy="914400"/>
+          </a:xfrm>
+          <a:prstGeom prst="rect">
+            <a:avLst/>
+          </a:prstGeom>
+          <a:noFill/>
+        </p:spPr>
+        <p:txBody>
+          <a:bodyPr wrap="square">
+            <a:spAutoFit/>
+          </a:bodyPr>
+          <a:lstStyle/>
+          <a:p>
+            <a:pPr algn="ctr"/>
+            <a:r>
+              <a:rPr sz="1100" b="0" i="0">
+                <a:solidFill>
+                  <a:srgbClr val="CCCCCC"/>
+                </a:solidFill>
+              </a:rPr>
+              <a:t>Too many requests too fast.
+System says 'Please wait'.
+Cost to us: $0</a:t>
+            </a:r>
+          </a:p>
+        </p:txBody>
+      </p:sp>
+      <p:sp>
+        <p:nvSpPr>
+          <p:cNvPr id="30" name="Rectangle 29"/>
+          <p:cNvSpPr/>
+          <p:nvPr/>
+        </p:nvSpPr>
+        <p:spPr>
+          <a:xfrm>
+            <a:off x="320040" y="4754880"/>
+            <a:ext cx="11521440" cy="1417320"/>
+          </a:xfrm>
+          <a:prstGeom prst="rect">
+            <a:avLst/>
+          </a:prstGeom>
+          <a:solidFill>
+            <a:srgbClr val="0F3D6E"/>
+          </a:solidFill>
+          <a:ln w="19050">
+            <a:solidFill>
+              <a:srgbClr val="FFD700"/>
+            </a:solidFill>
+          </a:ln>
+        </p:spPr>
+        <p:style>
+          <a:lnRef idx="1">
+            <a:schemeClr val="accent1"/>
+          </a:lnRef>
+          <a:fillRef idx="3">
+            <a:schemeClr val="accent1"/>
+          </a:fillRef>
+          <a:effectRef idx="2">
+            <a:schemeClr val="accent1"/>
+          </a:effectRef>
+          <a:fontRef idx="minor">
+            <a:schemeClr val="lt1"/>
+          </a:fontRef>
+        </p:style>
+        <p:txBody>
+          <a:bodyPr rtlCol="0" anchor="ctr"/>
+          <a:lstStyle/>
+          <a:p>
+            <a:pPr algn="ctr"/>
+          </a:p>
+        </p:txBody>
+      </p:sp>
+      <p:sp>
+        <p:nvSpPr>
+          <p:cNvPr id="31" name="TextBox 30"/>
+          <p:cNvSpPr txBox="1"/>
+          <p:nvPr/>
+        </p:nvSpPr>
+        <p:spPr>
+          <a:xfrm>
+            <a:off x="502920" y="4800600"/>
+            <a:ext cx="5486400" cy="411480"/>
+          </a:xfrm>
+          <a:prstGeom prst="rect">
+            <a:avLst/>
+          </a:prstGeom>
+          <a:noFill/>
+        </p:spPr>
+        <p:txBody>
+          <a:bodyPr wrap="square">
+            <a:spAutoFit/>
+          </a:bodyPr>
+          <a:lstStyle/>
+          <a:p>
+            <a:pPr algn="l"/>
+            <a:r>
+              <a:rPr sz="1400" b="1" i="0">
+                <a:solidFill>
+                  <a:srgbClr val="FFD700"/>
+                </a:solidFill>
+              </a:rPr>
+              <a:t>🔑  Key Takeaway for the Business</a:t>
+            </a:r>
+          </a:p>
+        </p:txBody>
+      </p:sp>
+      <p:sp>
+        <p:nvSpPr>
+          <p:cNvPr id="32" name="TextBox 31"/>
+          <p:cNvSpPr txBox="1"/>
+          <p:nvPr/>
+        </p:nvSpPr>
+        <p:spPr>
+          <a:xfrm>
+            <a:off x="502920" y="5166360"/>
+            <a:ext cx="11064240" cy="914400"/>
+          </a:xfrm>
+          <a:prstGeom prst="rect">
+            <a:avLst/>
+          </a:prstGeom>
+          <a:noFill/>
+        </p:spPr>
+        <p:txBody>
+          <a:bodyPr wrap="square">
+            <a:spAutoFit/>
+          </a:bodyPr>
+          <a:lstStyle/>
+          <a:p>
+            <a:pPr>
+              <a:spcBef>
+                <a:spcPts val="600"/>
+              </a:spcBef>
+            </a:pPr>
+            <a:r>
+              <a:rPr sz="1200">
+                <a:solidFill>
+                  <a:srgbClr val="FFFFFF"/>
+                </a:solidFill>
+              </a:rPr>
+              <a:t>✔  Only real users on our genuine app can ever reach the 'SMS Sent' step — protecting our budget automatically.</a:t>
+            </a:r>
+          </a:p>
+          <a:p>
+            <a:pPr>
+              <a:spcBef>
+                <a:spcPts val="600"/>
+              </a:spcBef>
+            </a:pPr>
+            <a:r>
+              <a:rPr sz="1200">
+                <a:solidFill>
+                  <a:srgbClr val="FFFFFF"/>
+                </a:solidFill>
+              </a:rPr>
+              <a:t>✔  The system is fully invisible to legitimate customers and requires no manual intervention.</a:t>
+            </a:r>
+          </a:p>
+          <a:p>
+            <a:pPr>
+              <a:spcBef>
+                <a:spcPts val="600"/>
+              </a:spcBef>
+            </a:pPr>
+            <a:r>
+              <a:rPr sz="1200">
+                <a:solidFill>
+                  <a:srgbClr val="FFFFFF"/>
+                </a:solidFill>
+              </a:rPr>
+              <a:t>✔  Both checkpoints run in under 50 milliseconds — no perceptible delay for users.</a:t>
+            </a:r>
+          </a:p>
+        </p:txBody>
+      </p:sp>
+      <p:sp>
+        <p:nvSpPr>
+          <p:cNvPr id="33" name="Rectangle 32"/>
+          <p:cNvSpPr/>
+          <p:nvPr/>
+        </p:nvSpPr>
+        <p:spPr>
+          <a:xfrm>
+            <a:off x="0" y="6537960"/>
+            <a:ext cx="12188952" cy="320040"/>
+          </a:xfrm>
+          <a:prstGeom prst="rect">
+            <a:avLst/>
+          </a:prstGeom>
+          <a:solidFill>
+            <a:srgbClr val="0F3D6E"/>
+          </a:solidFill>
+          <a:ln>
+            <a:noFill/>
+          </a:ln>
+        </p:spPr>
+        <p:style>
+          <a:lnRef idx="1">
+            <a:schemeClr val="accent1"/>
+          </a:lnRef>
+          <a:fillRef idx="3">
+            <a:schemeClr val="accent1"/>
+          </a:fillRef>
+          <a:effectRef idx="2">
+            <a:schemeClr val="accent1"/>
+          </a:effectRef>
+          <a:fontRef idx="minor">
+            <a:schemeClr val="lt1"/>
+          </a:fontRef>
+        </p:style>
+        <p:txBody>
+          <a:bodyPr rtlCol="0" anchor="ctr"/>
+          <a:lstStyle/>
+          <a:p>
+            <a:pPr algn="ctr"/>
+          </a:p>
+        </p:txBody>
+      </p:sp>
+      <p:sp>
+        <p:nvSpPr>
+          <p:cNvPr id="34" name="TextBox 33"/>
           <p:cNvSpPr txBox="1"/>
           <p:nvPr/>
         </p:nvSpPr>

</xml_diff>

<commit_message>
Retheme all 6 slides: white background, corporate green (#3DAA35) + blue (#1F5C9E) palette
Co-authored-by: labanlaban <126345013+labanlaban@users.noreply.github.com>
</commit_message>
<xml_diff>
--- a/sms_pumping_defence.pptx
+++ b/sms_pumping_defence.pptx
@@ -3089,7 +3089,7 @@
     <p:bg>
       <p:bgPr>
         <a:solidFill>
-          <a:srgbClr val="1A1A2E"/>
+          <a:srgbClr val="FFFFFF"/>
         </a:solidFill>
         <a:effectLst/>
       </p:bgPr>
@@ -3116,7 +3116,7 @@
             <a:avLst/>
           </a:prstGeom>
           <a:solidFill>
-            <a:srgbClr val="0F3D6E"/>
+            <a:srgbClr val="3DAA35"/>
           </a:solidFill>
           <a:ln>
             <a:noFill/>
@@ -3152,8 +3152,8 @@
         </p:nvSpPr>
         <p:spPr>
           <a:xfrm>
-            <a:off x="182880" y="73152"/>
-            <a:ext cx="2743200" cy="457200"/>
+            <a:off x="9875520" y="73152"/>
+            <a:ext cx="2103120" cy="457200"/>
           </a:xfrm>
           <a:prstGeom prst="rect">
             <a:avLst/>
@@ -3166,11 +3166,11 @@
           </a:bodyPr>
           <a:lstStyle/>
           <a:p>
-            <a:pPr algn="l"/>
+            <a:pPr algn="r"/>
             <a:r>
               <a:rPr sz="1000" b="0" i="0">
                 <a:solidFill>
-                  <a:srgbClr val="CCCCCC"/>
+                  <a:srgbClr val="FFFFFF"/>
                 </a:solidFill>
               </a:rPr>
               <a:t>Slide 1 of 6</a:t>
@@ -3221,13 +3221,13 @@
         <p:spPr>
           <a:xfrm>
             <a:off x="0" y="658368"/>
-            <a:ext cx="12188952" cy="54864"/>
+            <a:ext cx="12188952" cy="45720"/>
           </a:xfrm>
           <a:prstGeom prst="rect">
             <a:avLst/>
           </a:prstGeom>
           <a:solidFill>
-            <a:srgbClr val="E94F37"/>
+            <a:srgbClr val="1F5C9E"/>
           </a:solidFill>
           <a:ln>
             <a:noFill/>
@@ -3270,11 +3270,11 @@
             <a:avLst/>
           </a:prstGeom>
           <a:solidFill>
-            <a:srgbClr val="0F3D6E"/>
+            <a:srgbClr val="EBF7EA"/>
           </a:solidFill>
           <a:ln w="19050">
             <a:solidFill>
-              <a:srgbClr val="E94F37"/>
+              <a:srgbClr val="3DAA35"/>
             </a:solidFill>
           </a:ln>
         </p:spPr>
@@ -3302,93 +3302,23 @@
       </p:sp>
       <p:sp>
         <p:nvSpPr>
-          <p:cNvPr id="7" name="TextBox 6"/>
-          <p:cNvSpPr txBox="1"/>
-          <p:nvPr/>
-        </p:nvSpPr>
-        <p:spPr>
-          <a:xfrm>
-            <a:off x="438912" y="1024128"/>
-            <a:ext cx="5303520" cy="457200"/>
-          </a:xfrm>
-          <a:prstGeom prst="rect">
-            <a:avLst/>
-          </a:prstGeom>
-          <a:noFill/>
-        </p:spPr>
-        <p:txBody>
-          <a:bodyPr wrap="square">
-            <a:spAutoFit/>
-          </a:bodyPr>
-          <a:lstStyle/>
-          <a:p>
-            <a:pPr algn="l"/>
-            <a:r>
-              <a:rPr sz="1500" b="1" i="0">
-                <a:solidFill>
-                  <a:srgbClr val="FFD700"/>
-                </a:solidFill>
-              </a:rPr>
-              <a:t>📌  The Situation</a:t>
-            </a:r>
-          </a:p>
-        </p:txBody>
-      </p:sp>
-      <p:sp>
-        <p:nvSpPr>
-          <p:cNvPr id="8" name="TextBox 7"/>
-          <p:cNvSpPr txBox="1"/>
-          <p:nvPr/>
-        </p:nvSpPr>
-        <p:spPr>
-          <a:xfrm>
-            <a:off x="438912" y="1508760"/>
-            <a:ext cx="5248655" cy="1828799"/>
-          </a:xfrm>
-          <a:prstGeom prst="rect">
-            <a:avLst/>
-          </a:prstGeom>
-          <a:noFill/>
-        </p:spPr>
-        <p:txBody>
-          <a:bodyPr wrap="square">
-            <a:spAutoFit/>
-          </a:bodyPr>
-          <a:lstStyle/>
-          <a:p>
-            <a:pPr algn="l"/>
-            <a:r>
-              <a:rPr sz="1300" b="0" i="0">
-                <a:solidFill>
-                  <a:srgbClr val="FFFFFF"/>
-                </a:solidFill>
-              </a:rPr>
-              <a:t>We transitioned to Twilio as our communication provider for sending One-Time Passwords (OTPs) via SMS.</a:t>
-            </a:r>
-          </a:p>
-        </p:txBody>
-      </p:sp>
-      <p:sp>
-        <p:nvSpPr>
-          <p:cNvPr id="9" name="Rectangle 8"/>
+          <p:cNvPr id="7" name="Rectangle 6"/>
           <p:cNvSpPr/>
           <p:nvPr/>
         </p:nvSpPr>
         <p:spPr>
           <a:xfrm>
-            <a:off x="6217920" y="914400"/>
-            <a:ext cx="5577840" cy="2560320"/>
+            <a:off x="274320" y="914400"/>
+            <a:ext cx="5577840" cy="475488"/>
           </a:xfrm>
           <a:prstGeom prst="rect">
             <a:avLst/>
           </a:prstGeom>
           <a:solidFill>
-            <a:srgbClr val="0F3D6E"/>
+            <a:srgbClr val="3DAA35"/>
           </a:solidFill>
-          <a:ln w="19050">
-            <a:solidFill>
-              <a:srgbClr val="E94F37"/>
-            </a:solidFill>
+          <a:ln>
+            <a:noFill/>
           </a:ln>
         </p:spPr>
         <p:style>
@@ -3415,14 +3345,14 @@
       </p:sp>
       <p:sp>
         <p:nvSpPr>
-          <p:cNvPr id="10" name="TextBox 9"/>
+          <p:cNvPr id="8" name="TextBox 7"/>
           <p:cNvSpPr txBox="1"/>
           <p:nvPr/>
         </p:nvSpPr>
         <p:spPr>
           <a:xfrm>
-            <a:off x="6382512" y="1024128"/>
-            <a:ext cx="5303520" cy="457200"/>
+            <a:off x="438912" y="978408"/>
+            <a:ext cx="5303520" cy="384048"/>
           </a:xfrm>
           <a:prstGeom prst="rect">
             <a:avLst/>
@@ -3439,23 +3369,23 @@
             <a:r>
               <a:rPr sz="1500" b="1" i="0">
                 <a:solidFill>
-                  <a:srgbClr val="FFD700"/>
+                  <a:srgbClr val="FFFFFF"/>
                 </a:solidFill>
               </a:rPr>
-              <a:t>⚠️  The Problem</a:t>
-            </a:r>
-          </a:p>
-        </p:txBody>
-      </p:sp>
-      <p:sp>
-        <p:nvSpPr>
-          <p:cNvPr id="11" name="TextBox 10"/>
+              <a:t>📌  The Situation</a:t>
+            </a:r>
+          </a:p>
+        </p:txBody>
+      </p:sp>
+      <p:sp>
+        <p:nvSpPr>
+          <p:cNvPr id="9" name="TextBox 8"/>
           <p:cNvSpPr txBox="1"/>
           <p:nvPr/>
         </p:nvSpPr>
         <p:spPr>
           <a:xfrm>
-            <a:off x="6382512" y="1508760"/>
+            <a:off x="438912" y="1508760"/>
             <a:ext cx="5248655" cy="1828799"/>
           </a:xfrm>
           <a:prstGeom prst="rect">
@@ -3473,34 +3403,34 @@
             <a:r>
               <a:rPr sz="1300" b="0" i="0">
                 <a:solidFill>
-                  <a:srgbClr val="FFFFFF"/>
+                  <a:srgbClr val="1A1A2E"/>
                 </a:solidFill>
               </a:rPr>
-              <a:t>Shortly after this change, we noticed a massive spike in unexplainable SMS costs.</a:t>
-            </a:r>
-          </a:p>
-        </p:txBody>
-      </p:sp>
-      <p:sp>
-        <p:nvSpPr>
-          <p:cNvPr id="12" name="Rectangle 11"/>
+              <a:t>We transitioned to Twilio as our communication provider for sending One-Time Passwords (OTPs) via SMS.</a:t>
+            </a:r>
+          </a:p>
+        </p:txBody>
+      </p:sp>
+      <p:sp>
+        <p:nvSpPr>
+          <p:cNvPr id="10" name="Rectangle 9"/>
           <p:cNvSpPr/>
           <p:nvPr/>
         </p:nvSpPr>
         <p:spPr>
           <a:xfrm>
-            <a:off x="274320" y="3703320"/>
+            <a:off x="6217920" y="914400"/>
             <a:ext cx="5577840" cy="2560320"/>
           </a:xfrm>
           <a:prstGeom prst="rect">
             <a:avLst/>
           </a:prstGeom>
           <a:solidFill>
-            <a:srgbClr val="0F3D6E"/>
+            <a:srgbClr val="EBF7EA"/>
           </a:solidFill>
           <a:ln w="19050">
             <a:solidFill>
-              <a:srgbClr val="E94F37"/>
+              <a:srgbClr val="3DAA35"/>
             </a:solidFill>
           </a:ln>
         </p:spPr>
@@ -3528,93 +3458,23 @@
       </p:sp>
       <p:sp>
         <p:nvSpPr>
-          <p:cNvPr id="13" name="TextBox 12"/>
-          <p:cNvSpPr txBox="1"/>
-          <p:nvPr/>
-        </p:nvSpPr>
-        <p:spPr>
-          <a:xfrm>
-            <a:off x="438912" y="3813048"/>
-            <a:ext cx="5303520" cy="457200"/>
-          </a:xfrm>
-          <a:prstGeom prst="rect">
-            <a:avLst/>
-          </a:prstGeom>
-          <a:noFill/>
-        </p:spPr>
-        <p:txBody>
-          <a:bodyPr wrap="square">
-            <a:spAutoFit/>
-          </a:bodyPr>
-          <a:lstStyle/>
-          <a:p>
-            <a:pPr algn="l"/>
-            <a:r>
-              <a:rPr sz="1500" b="1" i="0">
-                <a:solidFill>
-                  <a:srgbClr val="FFD700"/>
-                </a:solidFill>
-              </a:rPr>
-              <a:t>🔍  The Root Cause</a:t>
-            </a:r>
-          </a:p>
-        </p:txBody>
-      </p:sp>
-      <p:sp>
-        <p:nvSpPr>
-          <p:cNvPr id="14" name="TextBox 13"/>
-          <p:cNvSpPr txBox="1"/>
-          <p:nvPr/>
-        </p:nvSpPr>
-        <p:spPr>
-          <a:xfrm>
-            <a:off x="438912" y="4297680"/>
-            <a:ext cx="5248655" cy="1828799"/>
-          </a:xfrm>
-          <a:prstGeom prst="rect">
-            <a:avLst/>
-          </a:prstGeom>
-          <a:noFill/>
-        </p:spPr>
-        <p:txBody>
-          <a:bodyPr wrap="square">
-            <a:spAutoFit/>
-          </a:bodyPr>
-          <a:lstStyle/>
-          <a:p>
-            <a:pPr algn="l"/>
-            <a:r>
-              <a:rPr sz="1300" b="0" i="0">
-                <a:solidFill>
-                  <a:srgbClr val="FFFFFF"/>
-                </a:solidFill>
-              </a:rPr>
-              <a:t>A huge volume of OTPs was triggered for random phone numbers — primarily based in Pakistan.</a:t>
-            </a:r>
-          </a:p>
-        </p:txBody>
-      </p:sp>
-      <p:sp>
-        <p:nvSpPr>
-          <p:cNvPr id="15" name="Rectangle 14"/>
+          <p:cNvPr id="11" name="Rectangle 10"/>
           <p:cNvSpPr/>
           <p:nvPr/>
         </p:nvSpPr>
         <p:spPr>
           <a:xfrm>
-            <a:off x="6217920" y="3703320"/>
-            <a:ext cx="5577840" cy="2560320"/>
+            <a:off x="6217920" y="914400"/>
+            <a:ext cx="5577840" cy="475488"/>
           </a:xfrm>
           <a:prstGeom prst="rect">
             <a:avLst/>
           </a:prstGeom>
           <a:solidFill>
-            <a:srgbClr val="0F3D6E"/>
+            <a:srgbClr val="3DAA35"/>
           </a:solidFill>
-          <a:ln w="19050">
-            <a:solidFill>
-              <a:srgbClr val="E94F37"/>
-            </a:solidFill>
+          <a:ln>
+            <a:noFill/>
           </a:ln>
         </p:spPr>
         <p:style>
@@ -3641,14 +3501,14 @@
       </p:sp>
       <p:sp>
         <p:nvSpPr>
-          <p:cNvPr id="16" name="TextBox 15"/>
+          <p:cNvPr id="12" name="TextBox 11"/>
           <p:cNvSpPr txBox="1"/>
           <p:nvPr/>
         </p:nvSpPr>
         <p:spPr>
           <a:xfrm>
-            <a:off x="6382512" y="3813048"/>
-            <a:ext cx="5303520" cy="457200"/>
+            <a:off x="6382512" y="978408"/>
+            <a:ext cx="5303520" cy="384048"/>
           </a:xfrm>
           <a:prstGeom prst="rect">
             <a:avLst/>
@@ -3665,23 +3525,23 @@
             <a:r>
               <a:rPr sz="1500" b="1" i="0">
                 <a:solidFill>
-                  <a:srgbClr val="FFD700"/>
+                  <a:srgbClr val="FFFFFF"/>
                 </a:solidFill>
               </a:rPr>
-              <a:t>🤖  What This Is</a:t>
-            </a:r>
-          </a:p>
-        </p:txBody>
-      </p:sp>
-      <p:sp>
-        <p:nvSpPr>
-          <p:cNvPr id="17" name="TextBox 16"/>
+              <a:t>⚠️  The Problem</a:t>
+            </a:r>
+          </a:p>
+        </p:txBody>
+      </p:sp>
+      <p:sp>
+        <p:nvSpPr>
+          <p:cNvPr id="13" name="TextBox 12"/>
           <p:cNvSpPr txBox="1"/>
           <p:nvPr/>
         </p:nvSpPr>
         <p:spPr>
           <a:xfrm>
-            <a:off x="6382512" y="4297680"/>
+            <a:off x="6382512" y="1508760"/>
             <a:ext cx="5248655" cy="1828799"/>
           </a:xfrm>
           <a:prstGeom prst="rect">
@@ -3699,33 +3559,35 @@
             <a:r>
               <a:rPr sz="1300" b="0" i="0">
                 <a:solidFill>
-                  <a:srgbClr val="FFFFFF"/>
+                  <a:srgbClr val="1A1A2E"/>
                 </a:solidFill>
               </a:rPr>
-              <a:t>"SMS Pumping" / "Toll Fraud" — automated bots trigger expensive SMS messages to international numbers to steal a fraction of routing fees.</a:t>
-            </a:r>
-          </a:p>
-        </p:txBody>
-      </p:sp>
-      <p:sp>
-        <p:nvSpPr>
-          <p:cNvPr id="18" name="Rectangle 17"/>
+              <a:t>Shortly after this change, we noticed a massive spike in unexplainable SMS costs.</a:t>
+            </a:r>
+          </a:p>
+        </p:txBody>
+      </p:sp>
+      <p:sp>
+        <p:nvSpPr>
+          <p:cNvPr id="14" name="Rectangle 13"/>
           <p:cNvSpPr/>
           <p:nvPr/>
         </p:nvSpPr>
         <p:spPr>
           <a:xfrm>
-            <a:off x="0" y="6537960"/>
-            <a:ext cx="12188952" cy="320040"/>
+            <a:off x="274320" y="3703320"/>
+            <a:ext cx="5577840" cy="2560320"/>
           </a:xfrm>
           <a:prstGeom prst="rect">
             <a:avLst/>
           </a:prstGeom>
           <a:solidFill>
-            <a:srgbClr val="0F3D6E"/>
+            <a:srgbClr val="EBF7EA"/>
           </a:solidFill>
-          <a:ln>
-            <a:noFill/>
+          <a:ln w="19050">
+            <a:solidFill>
+              <a:srgbClr val="3DAA35"/>
+            </a:solidFill>
           </a:ln>
         </p:spPr>
         <p:style>
@@ -3752,14 +3614,57 @@
       </p:sp>
       <p:sp>
         <p:nvSpPr>
-          <p:cNvPr id="19" name="TextBox 18"/>
+          <p:cNvPr id="15" name="Rectangle 14"/>
+          <p:cNvSpPr/>
+          <p:nvPr/>
+        </p:nvSpPr>
+        <p:spPr>
+          <a:xfrm>
+            <a:off x="274320" y="3703320"/>
+            <a:ext cx="5577840" cy="475488"/>
+          </a:xfrm>
+          <a:prstGeom prst="rect">
+            <a:avLst/>
+          </a:prstGeom>
+          <a:solidFill>
+            <a:srgbClr val="3DAA35"/>
+          </a:solidFill>
+          <a:ln>
+            <a:noFill/>
+          </a:ln>
+        </p:spPr>
+        <p:style>
+          <a:lnRef idx="1">
+            <a:schemeClr val="accent1"/>
+          </a:lnRef>
+          <a:fillRef idx="3">
+            <a:schemeClr val="accent1"/>
+          </a:fillRef>
+          <a:effectRef idx="2">
+            <a:schemeClr val="accent1"/>
+          </a:effectRef>
+          <a:fontRef idx="minor">
+            <a:schemeClr val="lt1"/>
+          </a:fontRef>
+        </p:style>
+        <p:txBody>
+          <a:bodyPr rtlCol="0" anchor="ctr"/>
+          <a:lstStyle/>
+          <a:p>
+            <a:pPr algn="ctr"/>
+          </a:p>
+        </p:txBody>
+      </p:sp>
+      <p:sp>
+        <p:nvSpPr>
+          <p:cNvPr id="16" name="TextBox 15"/>
           <p:cNvSpPr txBox="1"/>
           <p:nvPr/>
         </p:nvSpPr>
         <p:spPr>
           <a:xfrm>
-            <a:off x="274320" y="6565392"/>
-            <a:ext cx="11887200" cy="256032"/>
+            <a:off x="438912" y="3767328"/>
+            <a:ext cx="5303520" cy="384048"/>
           </a:xfrm>
           <a:prstGeom prst="rect">
             <a:avLst/>
@@ -3774,9 +3679,276 @@
           <a:p>
             <a:pPr algn="l"/>
             <a:r>
+              <a:rPr sz="1500" b="1" i="0">
+                <a:solidFill>
+                  <a:srgbClr val="FFFFFF"/>
+                </a:solidFill>
+              </a:rPr>
+              <a:t>🔍  The Root Cause</a:t>
+            </a:r>
+          </a:p>
+        </p:txBody>
+      </p:sp>
+      <p:sp>
+        <p:nvSpPr>
+          <p:cNvPr id="17" name="TextBox 16"/>
+          <p:cNvSpPr txBox="1"/>
+          <p:nvPr/>
+        </p:nvSpPr>
+        <p:spPr>
+          <a:xfrm>
+            <a:off x="438912" y="4297680"/>
+            <a:ext cx="5248655" cy="1828799"/>
+          </a:xfrm>
+          <a:prstGeom prst="rect">
+            <a:avLst/>
+          </a:prstGeom>
+          <a:noFill/>
+        </p:spPr>
+        <p:txBody>
+          <a:bodyPr wrap="square">
+            <a:spAutoFit/>
+          </a:bodyPr>
+          <a:lstStyle/>
+          <a:p>
+            <a:pPr algn="l"/>
+            <a:r>
+              <a:rPr sz="1300" b="0" i="0">
+                <a:solidFill>
+                  <a:srgbClr val="1A1A2E"/>
+                </a:solidFill>
+              </a:rPr>
+              <a:t>A huge volume of OTPs was triggered for random phone numbers — primarily based in Pakistan.</a:t>
+            </a:r>
+          </a:p>
+        </p:txBody>
+      </p:sp>
+      <p:sp>
+        <p:nvSpPr>
+          <p:cNvPr id="18" name="Rectangle 17"/>
+          <p:cNvSpPr/>
+          <p:nvPr/>
+        </p:nvSpPr>
+        <p:spPr>
+          <a:xfrm>
+            <a:off x="6217920" y="3703320"/>
+            <a:ext cx="5577840" cy="2560320"/>
+          </a:xfrm>
+          <a:prstGeom prst="rect">
+            <a:avLst/>
+          </a:prstGeom>
+          <a:solidFill>
+            <a:srgbClr val="EBF7EA"/>
+          </a:solidFill>
+          <a:ln w="19050">
+            <a:solidFill>
+              <a:srgbClr val="3DAA35"/>
+            </a:solidFill>
+          </a:ln>
+        </p:spPr>
+        <p:style>
+          <a:lnRef idx="1">
+            <a:schemeClr val="accent1"/>
+          </a:lnRef>
+          <a:fillRef idx="3">
+            <a:schemeClr val="accent1"/>
+          </a:fillRef>
+          <a:effectRef idx="2">
+            <a:schemeClr val="accent1"/>
+          </a:effectRef>
+          <a:fontRef idx="minor">
+            <a:schemeClr val="lt1"/>
+          </a:fontRef>
+        </p:style>
+        <p:txBody>
+          <a:bodyPr rtlCol="0" anchor="ctr"/>
+          <a:lstStyle/>
+          <a:p>
+            <a:pPr algn="ctr"/>
+          </a:p>
+        </p:txBody>
+      </p:sp>
+      <p:sp>
+        <p:nvSpPr>
+          <p:cNvPr id="19" name="Rectangle 18"/>
+          <p:cNvSpPr/>
+          <p:nvPr/>
+        </p:nvSpPr>
+        <p:spPr>
+          <a:xfrm>
+            <a:off x="6217920" y="3703320"/>
+            <a:ext cx="5577840" cy="475488"/>
+          </a:xfrm>
+          <a:prstGeom prst="rect">
+            <a:avLst/>
+          </a:prstGeom>
+          <a:solidFill>
+            <a:srgbClr val="3DAA35"/>
+          </a:solidFill>
+          <a:ln>
+            <a:noFill/>
+          </a:ln>
+        </p:spPr>
+        <p:style>
+          <a:lnRef idx="1">
+            <a:schemeClr val="accent1"/>
+          </a:lnRef>
+          <a:fillRef idx="3">
+            <a:schemeClr val="accent1"/>
+          </a:fillRef>
+          <a:effectRef idx="2">
+            <a:schemeClr val="accent1"/>
+          </a:effectRef>
+          <a:fontRef idx="minor">
+            <a:schemeClr val="lt1"/>
+          </a:fontRef>
+        </p:style>
+        <p:txBody>
+          <a:bodyPr rtlCol="0" anchor="ctr"/>
+          <a:lstStyle/>
+          <a:p>
+            <a:pPr algn="ctr"/>
+          </a:p>
+        </p:txBody>
+      </p:sp>
+      <p:sp>
+        <p:nvSpPr>
+          <p:cNvPr id="20" name="TextBox 19"/>
+          <p:cNvSpPr txBox="1"/>
+          <p:nvPr/>
+        </p:nvSpPr>
+        <p:spPr>
+          <a:xfrm>
+            <a:off x="6382512" y="3767328"/>
+            <a:ext cx="5303520" cy="384048"/>
+          </a:xfrm>
+          <a:prstGeom prst="rect">
+            <a:avLst/>
+          </a:prstGeom>
+          <a:noFill/>
+        </p:spPr>
+        <p:txBody>
+          <a:bodyPr wrap="square">
+            <a:spAutoFit/>
+          </a:bodyPr>
+          <a:lstStyle/>
+          <a:p>
+            <a:pPr algn="l"/>
+            <a:r>
+              <a:rPr sz="1500" b="1" i="0">
+                <a:solidFill>
+                  <a:srgbClr val="FFFFFF"/>
+                </a:solidFill>
+              </a:rPr>
+              <a:t>🤖  What This Is</a:t>
+            </a:r>
+          </a:p>
+        </p:txBody>
+      </p:sp>
+      <p:sp>
+        <p:nvSpPr>
+          <p:cNvPr id="21" name="TextBox 20"/>
+          <p:cNvSpPr txBox="1"/>
+          <p:nvPr/>
+        </p:nvSpPr>
+        <p:spPr>
+          <a:xfrm>
+            <a:off x="6382512" y="4297680"/>
+            <a:ext cx="5248655" cy="1828799"/>
+          </a:xfrm>
+          <a:prstGeom prst="rect">
+            <a:avLst/>
+          </a:prstGeom>
+          <a:noFill/>
+        </p:spPr>
+        <p:txBody>
+          <a:bodyPr wrap="square">
+            <a:spAutoFit/>
+          </a:bodyPr>
+          <a:lstStyle/>
+          <a:p>
+            <a:pPr algn="l"/>
+            <a:r>
+              <a:rPr sz="1300" b="0" i="0">
+                <a:solidFill>
+                  <a:srgbClr val="1A1A2E"/>
+                </a:solidFill>
+              </a:rPr>
+              <a:t>"SMS Pumping" / "Toll Fraud" — automated bots trigger expensive SMS messages to international numbers to steal a fraction of routing fees.</a:t>
+            </a:r>
+          </a:p>
+        </p:txBody>
+      </p:sp>
+      <p:sp>
+        <p:nvSpPr>
+          <p:cNvPr id="22" name="Rectangle 21"/>
+          <p:cNvSpPr/>
+          <p:nvPr/>
+        </p:nvSpPr>
+        <p:spPr>
+          <a:xfrm>
+            <a:off x="0" y="6537960"/>
+            <a:ext cx="12188952" cy="320040"/>
+          </a:xfrm>
+          <a:prstGeom prst="rect">
+            <a:avLst/>
+          </a:prstGeom>
+          <a:solidFill>
+            <a:srgbClr val="F0F0F2"/>
+          </a:solidFill>
+          <a:ln>
+            <a:noFill/>
+          </a:ln>
+        </p:spPr>
+        <p:style>
+          <a:lnRef idx="1">
+            <a:schemeClr val="accent1"/>
+          </a:lnRef>
+          <a:fillRef idx="3">
+            <a:schemeClr val="accent1"/>
+          </a:fillRef>
+          <a:effectRef idx="2">
+            <a:schemeClr val="accent1"/>
+          </a:effectRef>
+          <a:fontRef idx="minor">
+            <a:schemeClr val="lt1"/>
+          </a:fontRef>
+        </p:style>
+        <p:txBody>
+          <a:bodyPr rtlCol="0" anchor="ctr"/>
+          <a:lstStyle/>
+          <a:p>
+            <a:pPr algn="ctr"/>
+          </a:p>
+        </p:txBody>
+      </p:sp>
+      <p:sp>
+        <p:nvSpPr>
+          <p:cNvPr id="23" name="TextBox 22"/>
+          <p:cNvSpPr txBox="1"/>
+          <p:nvPr/>
+        </p:nvSpPr>
+        <p:spPr>
+          <a:xfrm>
+            <a:off x="274320" y="6565392"/>
+            <a:ext cx="11887200" cy="256032"/>
+          </a:xfrm>
+          <a:prstGeom prst="rect">
+            <a:avLst/>
+          </a:prstGeom>
+          <a:noFill/>
+        </p:spPr>
+        <p:txBody>
+          <a:bodyPr wrap="square">
+            <a:spAutoFit/>
+          </a:bodyPr>
+          <a:lstStyle/>
+          <a:p>
+            <a:pPr algn="l"/>
+            <a:r>
               <a:rPr sz="900" b="0" i="0">
                 <a:solidFill>
-                  <a:srgbClr val="CCCCCC"/>
+                  <a:srgbClr val="888899"/>
                 </a:solidFill>
               </a:rPr>
               <a:t>SMS Pumping Defence  |  Confidential</a:t>
@@ -3798,7 +3970,7 @@
     <p:bg>
       <p:bgPr>
         <a:solidFill>
-          <a:srgbClr val="1A1A2E"/>
+          <a:srgbClr val="FFFFFF"/>
         </a:solidFill>
         <a:effectLst/>
       </p:bgPr>
@@ -3825,7 +3997,7 @@
             <a:avLst/>
           </a:prstGeom>
           <a:solidFill>
-            <a:srgbClr val="0F3D6E"/>
+            <a:srgbClr val="3DAA35"/>
           </a:solidFill>
           <a:ln>
             <a:noFill/>
@@ -3861,8 +4033,8 @@
         </p:nvSpPr>
         <p:spPr>
           <a:xfrm>
-            <a:off x="182880" y="73152"/>
-            <a:ext cx="2743200" cy="457200"/>
+            <a:off x="9875520" y="73152"/>
+            <a:ext cx="2103120" cy="457200"/>
           </a:xfrm>
           <a:prstGeom prst="rect">
             <a:avLst/>
@@ -3875,11 +4047,11 @@
           </a:bodyPr>
           <a:lstStyle/>
           <a:p>
-            <a:pPr algn="l"/>
+            <a:pPr algn="r"/>
             <a:r>
               <a:rPr sz="1000" b="0" i="0">
                 <a:solidFill>
-                  <a:srgbClr val="CCCCCC"/>
+                  <a:srgbClr val="FFFFFF"/>
                 </a:solidFill>
               </a:rPr>
               <a:t>Slide 2 of 6</a:t>
@@ -3930,13 +4102,13 @@
         <p:spPr>
           <a:xfrm>
             <a:off x="0" y="658368"/>
-            <a:ext cx="12188952" cy="54864"/>
+            <a:ext cx="12188952" cy="45720"/>
           </a:xfrm>
           <a:prstGeom prst="rect">
             <a:avLst/>
           </a:prstGeom>
           <a:solidFill>
-            <a:srgbClr val="E94F37"/>
+            <a:srgbClr val="1F5C9E"/>
           </a:solidFill>
           <a:ln>
             <a:noFill/>
@@ -3990,7 +4162,7 @@
             <a:r>
               <a:rPr sz="1600" b="0" i="0">
                 <a:solidFill>
-                  <a:srgbClr val="CCCCCC"/>
+                  <a:srgbClr val="555566"/>
                 </a:solidFill>
               </a:rPr>
               <a:t>To permanently stop SMS Pumping and protect our budget, we implemented a robust, two-layered security checkpoint system on our backend.</a:t>
@@ -4024,7 +4196,7 @@
             <a:r>
               <a:rPr sz="1500" b="1" i="0">
                 <a:solidFill>
-                  <a:srgbClr val="FFD700"/>
+                  <a:srgbClr val="1F5C9E"/>
                 </a:solidFill>
               </a:rPr>
               <a:t>Both layers must be passed before we spend a single cent on an SMS.</a:t>
@@ -4047,11 +4219,11 @@
             <a:avLst/>
           </a:prstGeom>
           <a:solidFill>
-            <a:srgbClr val="0F3D6E"/>
+            <a:srgbClr val="E8F1FB"/>
           </a:solidFill>
           <a:ln w="25400">
             <a:solidFill>
-              <a:srgbClr val="E94F37"/>
+              <a:srgbClr val="1F5C9E"/>
             </a:solidFill>
           </a:ln>
         </p:spPr>
@@ -4092,7 +4264,7 @@
             <a:avLst/>
           </a:prstGeom>
           <a:solidFill>
-            <a:srgbClr val="E94F37"/>
+            <a:srgbClr val="1F5C9E"/>
           </a:solidFill>
           <a:ln>
             <a:noFill/>
@@ -4180,7 +4352,7 @@
             <a:r>
               <a:rPr sz="1300" b="0" i="0">
                 <a:solidFill>
-                  <a:srgbClr val="FFFFFF"/>
+                  <a:srgbClr val="1A1A2E"/>
                 </a:solidFill>
               </a:rPr>
               <a:t>Are you our real app?
@@ -4205,11 +4377,11 @@
             <a:avLst/>
           </a:prstGeom>
           <a:solidFill>
-            <a:srgbClr val="0F3D6E"/>
+            <a:srgbClr val="E8F1FB"/>
           </a:solidFill>
           <a:ln w="25400">
             <a:solidFill>
-              <a:srgbClr val="E94F37"/>
+              <a:srgbClr val="1F5C9E"/>
             </a:solidFill>
           </a:ln>
         </p:spPr>
@@ -4250,7 +4422,7 @@
             <a:avLst/>
           </a:prstGeom>
           <a:solidFill>
-            <a:srgbClr val="E94F37"/>
+            <a:srgbClr val="1F5C9E"/>
           </a:solidFill>
           <a:ln>
             <a:noFill/>
@@ -4338,7 +4510,7 @@
             <a:r>
               <a:rPr sz="1300" b="0" i="0">
                 <a:solidFill>
-                  <a:srgbClr val="FFFFFF"/>
+                  <a:srgbClr val="1A1A2E"/>
                 </a:solidFill>
               </a:rPr>
               <a:t>Are you requesting too fast?
@@ -4363,7 +4535,7 @@
             <a:avLst/>
           </a:prstGeom>
           <a:solidFill>
-            <a:srgbClr val="0F3D6E"/>
+            <a:srgbClr val="F0F0F2"/>
           </a:solidFill>
           <a:ln>
             <a:noFill/>
@@ -4417,7 +4589,7 @@
             <a:r>
               <a:rPr sz="900" b="0" i="0">
                 <a:solidFill>
-                  <a:srgbClr val="CCCCCC"/>
+                  <a:srgbClr val="888899"/>
                 </a:solidFill>
               </a:rPr>
               <a:t>SMS Pumping Defence  |  Confidential</a:t>
@@ -4439,7 +4611,7 @@
     <p:bg>
       <p:bgPr>
         <a:solidFill>
-          <a:srgbClr val="1A1A2E"/>
+          <a:srgbClr val="FFFFFF"/>
         </a:solidFill>
         <a:effectLst/>
       </p:bgPr>
@@ -4466,7 +4638,7 @@
             <a:avLst/>
           </a:prstGeom>
           <a:solidFill>
-            <a:srgbClr val="0F3D6E"/>
+            <a:srgbClr val="3DAA35"/>
           </a:solidFill>
           <a:ln>
             <a:noFill/>
@@ -4502,8 +4674,8 @@
         </p:nvSpPr>
         <p:spPr>
           <a:xfrm>
-            <a:off x="182880" y="73152"/>
-            <a:ext cx="2743200" cy="457200"/>
+            <a:off x="9875520" y="73152"/>
+            <a:ext cx="2103120" cy="457200"/>
           </a:xfrm>
           <a:prstGeom prst="rect">
             <a:avLst/>
@@ -4516,11 +4688,11 @@
           </a:bodyPr>
           <a:lstStyle/>
           <a:p>
-            <a:pPr algn="l"/>
+            <a:pPr algn="r"/>
             <a:r>
               <a:rPr sz="1000" b="0" i="0">
                 <a:solidFill>
-                  <a:srgbClr val="CCCCCC"/>
+                  <a:srgbClr val="FFFFFF"/>
                 </a:solidFill>
               </a:rPr>
               <a:t>Slide 3 of 6</a:t>
@@ -4571,13 +4743,13 @@
         <p:spPr>
           <a:xfrm>
             <a:off x="0" y="658368"/>
-            <a:ext cx="12188952" cy="54864"/>
+            <a:ext cx="12188952" cy="45720"/>
           </a:xfrm>
           <a:prstGeom prst="rect">
             <a:avLst/>
           </a:prstGeom>
           <a:solidFill>
-            <a:srgbClr val="E94F37"/>
+            <a:srgbClr val="1F5C9E"/>
           </a:solidFill>
           <a:ln>
             <a:noFill/>
@@ -4631,7 +4803,7 @@
             <a:r>
               <a:rPr sz="1800" b="1" i="0">
                 <a:solidFill>
-                  <a:srgbClr val="FFD700"/>
+                  <a:srgbClr val="1F5C9E"/>
                 </a:solidFill>
               </a:rPr>
               <a:t>🔒  AppRequestContextFilter  (Firebase App Check)</a:t>
@@ -4654,11 +4826,11 @@
             <a:avLst/>
           </a:prstGeom>
           <a:solidFill>
-            <a:srgbClr val="0F3D6E"/>
+            <a:srgbClr val="E8F1FB"/>
           </a:solidFill>
           <a:ln w="25400">
             <a:solidFill>
-              <a:srgbClr val="E94F37"/>
+              <a:srgbClr val="1F5C9E"/>
             </a:solidFill>
           </a:ln>
         </p:spPr>
@@ -4710,7 +4882,7 @@
             <a:r>
               <a:rPr sz="1400" b="1" i="0">
                 <a:solidFill>
-                  <a:srgbClr val="FFFFFF"/>
+                  <a:srgbClr val="1F5C9E"/>
                 </a:solidFill>
               </a:rPr>
               <a:t>📱  Real App</a:t>
@@ -4744,7 +4916,7 @@
             <a:r>
               <a:rPr sz="1200" b="0" i="0">
                 <a:solidFill>
-                  <a:srgbClr val="FFFFFF"/>
+                  <a:srgbClr val="1A1A2E"/>
                 </a:solidFill>
               </a:rPr>
               <a:t>Silently generates a
@@ -4769,11 +4941,11 @@
             <a:avLst/>
           </a:prstGeom>
           <a:solidFill>
-            <a:srgbClr val="0F3D6E"/>
+            <a:srgbClr val="E8F1FB"/>
           </a:solidFill>
           <a:ln w="25400">
             <a:solidFill>
-              <a:srgbClr val="E94F37"/>
+              <a:srgbClr val="1F5C9E"/>
             </a:solidFill>
           </a:ln>
         </p:spPr>
@@ -4825,7 +4997,7 @@
             <a:r>
               <a:rPr sz="1400" b="1" i="0">
                 <a:solidFill>
-                  <a:srgbClr val="FFFFFF"/>
+                  <a:srgbClr val="1F5C9E"/>
                 </a:solidFill>
               </a:rPr>
               <a:t>🚪  Gatekeeper</a:t>
@@ -4859,7 +5031,7 @@
             <a:r>
               <a:rPr sz="1200" b="0" i="0">
                 <a:solidFill>
-                  <a:srgbClr val="FFFFFF"/>
+                  <a:srgbClr val="1A1A2E"/>
                 </a:solidFill>
               </a:rPr>
               <a:t>Demands the token before
@@ -4884,11 +5056,11 @@
             <a:avLst/>
           </a:prstGeom>
           <a:solidFill>
-            <a:srgbClr val="8B0000"/>
+            <a:srgbClr val="FFEBEB"/>
           </a:solidFill>
           <a:ln w="25400">
             <a:solidFill>
-              <a:srgbClr val="FF4444"/>
+              <a:srgbClr val="CC2020"/>
             </a:solidFill>
           </a:ln>
         </p:spPr>
@@ -4940,7 +5112,7 @@
             <a:r>
               <a:rPr sz="1400" b="1" i="0">
                 <a:solidFill>
-                  <a:srgbClr val="FFD700"/>
+                  <a:srgbClr val="CC2020"/>
                 </a:solidFill>
               </a:rPr>
               <a:t>🤖  Bot / Script</a:t>
@@ -4974,7 +5146,7 @@
             <a:r>
               <a:rPr sz="1200" b="0" i="0">
                 <a:solidFill>
-                  <a:srgbClr val="FFFFFF"/>
+                  <a:srgbClr val="1A1A2E"/>
                 </a:solidFill>
               </a:rPr>
               <a:t>Cannot generate a valid token.
@@ -5010,7 +5182,7 @@
             <a:r>
               <a:rPr sz="2200" b="0" i="0">
                 <a:solidFill>
-                  <a:srgbClr val="E94F37"/>
+                  <a:srgbClr val="3DAA35"/>
                 </a:solidFill>
               </a:rPr>
               <a:t>➤</a:t>
@@ -5044,7 +5216,7 @@
             <a:r>
               <a:rPr sz="2200" b="0" i="0">
                 <a:solidFill>
-                  <a:srgbClr val="E94F37"/>
+                  <a:srgbClr val="3DAA35"/>
                 </a:solidFill>
               </a:rPr>
               <a:t>➤</a:t>
@@ -5067,11 +5239,11 @@
             <a:avLst/>
           </a:prstGeom>
           <a:solidFill>
-            <a:srgbClr val="E94F37"/>
+            <a:srgbClr val="3DAA35"/>
           </a:solidFill>
           <a:ln>
             <a:solidFill>
-              <a:srgbClr val="E94F37"/>
+              <a:srgbClr val="3DAA35"/>
             </a:solidFill>
           </a:ln>
         </p:spPr>
@@ -5161,7 +5333,7 @@
             <a:r>
               <a:rPr sz="1400">
                 <a:solidFill>
-                  <a:srgbClr val="FFFFFF"/>
+                  <a:srgbClr val="1A1A2E"/>
                 </a:solidFill>
               </a:rPr>
               <a:t>▸  Bot farms lack a real device running our genuine application.</a:t>
@@ -5176,7 +5348,7 @@
             <a:r>
               <a:rPr sz="1400">
                 <a:solidFill>
-                  <a:srgbClr val="FFFFFF"/>
+                  <a:srgbClr val="1A1A2E"/>
                 </a:solidFill>
               </a:rPr>
               <a:t>▸  Automated scripts cannot replicate the cryptographic token generation.</a:t>
@@ -5191,7 +5363,7 @@
             <a:r>
               <a:rPr sz="1400">
                 <a:solidFill>
-                  <a:srgbClr val="FFFFFF"/>
+                  <a:srgbClr val="1A1A2E"/>
                 </a:solidFill>
               </a:rPr>
               <a:t>▸  Rejection happens before any SMS is queued — zero Twilio spend.</a:t>
@@ -5214,7 +5386,7 @@
             <a:avLst/>
           </a:prstGeom>
           <a:solidFill>
-            <a:srgbClr val="0F3D6E"/>
+            <a:srgbClr val="F0F0F2"/>
           </a:solidFill>
           <a:ln>
             <a:noFill/>
@@ -5268,7 +5440,7 @@
             <a:r>
               <a:rPr sz="900" b="0" i="0">
                 <a:solidFill>
-                  <a:srgbClr val="CCCCCC"/>
+                  <a:srgbClr val="888899"/>
                 </a:solidFill>
               </a:rPr>
               <a:t>SMS Pumping Defence  |  Confidential</a:t>
@@ -5290,7 +5462,7 @@
     <p:bg>
       <p:bgPr>
         <a:solidFill>
-          <a:srgbClr val="1A1A2E"/>
+          <a:srgbClr val="FFFFFF"/>
         </a:solidFill>
         <a:effectLst/>
       </p:bgPr>
@@ -5317,7 +5489,7 @@
             <a:avLst/>
           </a:prstGeom>
           <a:solidFill>
-            <a:srgbClr val="0F3D6E"/>
+            <a:srgbClr val="3DAA35"/>
           </a:solidFill>
           <a:ln>
             <a:noFill/>
@@ -5353,8 +5525,8 @@
         </p:nvSpPr>
         <p:spPr>
           <a:xfrm>
-            <a:off x="182880" y="73152"/>
-            <a:ext cx="2743200" cy="457200"/>
+            <a:off x="9875520" y="73152"/>
+            <a:ext cx="2103120" cy="457200"/>
           </a:xfrm>
           <a:prstGeom prst="rect">
             <a:avLst/>
@@ -5367,11 +5539,11 @@
           </a:bodyPr>
           <a:lstStyle/>
           <a:p>
-            <a:pPr algn="l"/>
+            <a:pPr algn="r"/>
             <a:r>
               <a:rPr sz="1000" b="0" i="0">
                 <a:solidFill>
-                  <a:srgbClr val="CCCCCC"/>
+                  <a:srgbClr val="FFFFFF"/>
                 </a:solidFill>
               </a:rPr>
               <a:t>Slide 4 of 6</a:t>
@@ -5422,13 +5594,13 @@
         <p:spPr>
           <a:xfrm>
             <a:off x="0" y="658368"/>
-            <a:ext cx="12188952" cy="54864"/>
+            <a:ext cx="12188952" cy="45720"/>
           </a:xfrm>
           <a:prstGeom prst="rect">
             <a:avLst/>
           </a:prstGeom>
           <a:solidFill>
-            <a:srgbClr val="E94F37"/>
+            <a:srgbClr val="1F5C9E"/>
           </a:solidFill>
           <a:ln>
             <a:noFill/>
@@ -5482,7 +5654,7 @@
             <a:r>
               <a:rPr sz="1800" b="1" i="0">
                 <a:solidFill>
-                  <a:srgbClr val="FFD700"/>
+                  <a:srgbClr val="1F5C9E"/>
                 </a:solidFill>
               </a:rPr>
               <a:t>⏱️  SendOtpRateLimitAttribute</a:t>
@@ -5505,11 +5677,11 @@
             <a:avLst/>
           </a:prstGeom>
           <a:solidFill>
-            <a:srgbClr val="0F3D6E"/>
+            <a:srgbClr val="EBF7EA"/>
           </a:solidFill>
           <a:ln w="19050">
             <a:solidFill>
-              <a:srgbClr val="E94F37"/>
+              <a:srgbClr val="3DAA35"/>
             </a:solidFill>
           </a:ln>
         </p:spPr>
@@ -5550,7 +5722,7 @@
             <a:avLst/>
           </a:prstGeom>
           <a:solidFill>
-            <a:srgbClr val="E94F37"/>
+            <a:srgbClr val="3DAA35"/>
           </a:solidFill>
           <a:ln>
             <a:noFill/>
@@ -5638,7 +5810,7 @@
             <a:r>
               <a:rPr sz="1200" b="0" i="0">
                 <a:solidFill>
-                  <a:srgbClr val="FFFFFF"/>
+                  <a:srgbClr val="1A1A2E"/>
                 </a:solidFill>
               </a:rPr>
               <a:t>What if an attacker hijacks a real phone, or a legitimate user taps 'Send OTP' 50 times in a row?
@@ -5662,11 +5834,11 @@
             <a:avLst/>
           </a:prstGeom>
           <a:solidFill>
-            <a:srgbClr val="0F3D6E"/>
+            <a:srgbClr val="EBF7EA"/>
           </a:solidFill>
           <a:ln w="19050">
             <a:solidFill>
-              <a:srgbClr val="E94F37"/>
+              <a:srgbClr val="3DAA35"/>
             </a:solidFill>
           </a:ln>
         </p:spPr>
@@ -5707,7 +5879,7 @@
             <a:avLst/>
           </a:prstGeom>
           <a:solidFill>
-            <a:srgbClr val="E94F37"/>
+            <a:srgbClr val="3DAA35"/>
           </a:solidFill>
           <a:ln>
             <a:noFill/>
@@ -5795,7 +5967,7 @@
             <a:r>
               <a:rPr sz="1200" b="0" i="0">
                 <a:solidFill>
-                  <a:srgbClr val="FFFFFF"/>
+                  <a:srgbClr val="1A1A2E"/>
                 </a:solidFill>
               </a:rPr>
               <a:t>Tracks how often a specific user or device requests an OTP.
@@ -5820,11 +5992,11 @@
             <a:avLst/>
           </a:prstGeom>
           <a:solidFill>
-            <a:srgbClr val="0F3D6E"/>
+            <a:srgbClr val="EBF7EA"/>
           </a:solidFill>
           <a:ln w="19050">
             <a:solidFill>
-              <a:srgbClr val="E94F37"/>
+              <a:srgbClr val="3DAA35"/>
             </a:solidFill>
           </a:ln>
         </p:spPr>
@@ -5865,7 +6037,7 @@
             <a:avLst/>
           </a:prstGeom>
           <a:solidFill>
-            <a:srgbClr val="E94F37"/>
+            <a:srgbClr val="3DAA35"/>
           </a:solidFill>
           <a:ln>
             <a:noFill/>
@@ -5953,7 +6125,7 @@
             <a:r>
               <a:rPr sz="1200" b="0" i="0">
                 <a:solidFill>
-                  <a:srgbClr val="FFFFFF"/>
+                  <a:srgbClr val="1A1A2E"/>
                 </a:solidFill>
               </a:rPr>
               <a:t>Residual fraud is caught by this fail-safe layer.
@@ -5978,11 +6150,11 @@
             <a:avLst/>
           </a:prstGeom>
           <a:solidFill>
-            <a:srgbClr val="0F3D6E"/>
+            <a:srgbClr val="E8F1FB"/>
           </a:solidFill>
           <a:ln w="19050">
             <a:solidFill>
-              <a:srgbClr val="FFD700"/>
+              <a:srgbClr val="1F5C9E"/>
             </a:solidFill>
           </a:ln>
         </p:spPr>
@@ -6034,7 +6206,7 @@
             <a:r>
               <a:rPr sz="1400" b="1" i="0">
                 <a:solidFill>
-                  <a:srgbClr val="FFD700"/>
+                  <a:srgbClr val="1F5C9E"/>
                 </a:solidFill>
               </a:rPr>
               <a:t>🔐  Combined Defence Summary</a:t>
@@ -6072,7 +6244,7 @@
             <a:r>
               <a:rPr sz="1200">
                 <a:solidFill>
-                  <a:srgbClr val="FFFFFF"/>
+                  <a:srgbClr val="1A1A2E"/>
                 </a:solidFill>
               </a:rPr>
               <a:t>✔  Layer 1 (App Check) blocks ~99 %+ of bot traffic before any cost is incurred.</a:t>
@@ -6087,7 +6259,7 @@
             <a:r>
               <a:rPr sz="1200">
                 <a:solidFill>
-                  <a:srgbClr val="FFFFFF"/>
+                  <a:srgbClr val="1A1A2E"/>
                 </a:solidFill>
               </a:rPr>
               <a:t>✔  Layer 2 (Rate Limit) eliminates residual abuse and protects against edge cases.</a:t>
@@ -6110,7 +6282,7 @@
             <a:avLst/>
           </a:prstGeom>
           <a:solidFill>
-            <a:srgbClr val="0F3D6E"/>
+            <a:srgbClr val="F0F0F2"/>
           </a:solidFill>
           <a:ln>
             <a:noFill/>
@@ -6164,7 +6336,7 @@
             <a:r>
               <a:rPr sz="900" b="0" i="0">
                 <a:solidFill>
-                  <a:srgbClr val="CCCCCC"/>
+                  <a:srgbClr val="888899"/>
                 </a:solidFill>
               </a:rPr>
               <a:t>SMS Pumping Defence  |  Confidential</a:t>
@@ -6186,7 +6358,7 @@
     <p:bg>
       <p:bgPr>
         <a:solidFill>
-          <a:srgbClr val="1A1A2E"/>
+          <a:srgbClr val="FFFFFF"/>
         </a:solidFill>
         <a:effectLst/>
       </p:bgPr>
@@ -6213,7 +6385,7 @@
             <a:avLst/>
           </a:prstGeom>
           <a:solidFill>
-            <a:srgbClr val="0F3D6E"/>
+            <a:srgbClr val="3DAA35"/>
           </a:solidFill>
           <a:ln>
             <a:noFill/>
@@ -6249,8 +6421,8 @@
         </p:nvSpPr>
         <p:spPr>
           <a:xfrm>
-            <a:off x="182880" y="73152"/>
-            <a:ext cx="2743200" cy="457200"/>
+            <a:off x="9875520" y="73152"/>
+            <a:ext cx="2103120" cy="457200"/>
           </a:xfrm>
           <a:prstGeom prst="rect">
             <a:avLst/>
@@ -6263,11 +6435,11 @@
           </a:bodyPr>
           <a:lstStyle/>
           <a:p>
-            <a:pPr algn="l"/>
+            <a:pPr algn="r"/>
             <a:r>
               <a:rPr sz="1000" b="0" i="0">
                 <a:solidFill>
-                  <a:srgbClr val="CCCCCC"/>
+                  <a:srgbClr val="FFFFFF"/>
                 </a:solidFill>
               </a:rPr>
               <a:t>Slide 5 of 6</a:t>
@@ -6318,13 +6490,13 @@
         <p:spPr>
           <a:xfrm>
             <a:off x="0" y="658368"/>
-            <a:ext cx="12188952" cy="54864"/>
+            <a:ext cx="12188952" cy="45720"/>
           </a:xfrm>
           <a:prstGeom prst="rect">
             <a:avLst/>
           </a:prstGeom>
           <a:solidFill>
-            <a:srgbClr val="E94F37"/>
+            <a:srgbClr val="1F5C9E"/>
           </a:solidFill>
           <a:ln>
             <a:noFill/>
@@ -6367,11 +6539,11 @@
             <a:avLst/>
           </a:prstGeom>
           <a:solidFill>
-            <a:srgbClr val="0F3D6E"/>
+            <a:srgbClr val="EBF7EA"/>
           </a:solidFill>
           <a:ln w="19050">
             <a:solidFill>
-              <a:srgbClr val="E94F37"/>
+              <a:srgbClr val="3DAA35"/>
             </a:solidFill>
           </a:ln>
         </p:spPr>
@@ -6412,7 +6584,7 @@
             <a:avLst/>
           </a:prstGeom>
           <a:solidFill>
-            <a:srgbClr val="E94F37"/>
+            <a:srgbClr val="3DAA35"/>
           </a:solidFill>
           <a:ln>
             <a:noFill/>
@@ -6500,7 +6672,7 @@
             <a:r>
               <a:rPr sz="1300" b="0" i="0">
                 <a:solidFill>
-                  <a:srgbClr val="FFFFFF"/>
+                  <a:srgbClr val="1A1A2E"/>
                 </a:solidFill>
               </a:rPr>
               <a:t>We have successfully shut off the vulnerability that automated scripts were exploiting, saving the company from runaway Twilio invoices.
@@ -6524,11 +6696,11 @@
             <a:avLst/>
           </a:prstGeom>
           <a:solidFill>
-            <a:srgbClr val="0F3D6E"/>
+            <a:srgbClr val="EBF7EA"/>
           </a:solidFill>
           <a:ln w="19050">
             <a:solidFill>
-              <a:srgbClr val="E94F37"/>
+              <a:srgbClr val="3DAA35"/>
             </a:solidFill>
           </a:ln>
         </p:spPr>
@@ -6569,7 +6741,7 @@
             <a:avLst/>
           </a:prstGeom>
           <a:solidFill>
-            <a:srgbClr val="E94F37"/>
+            <a:srgbClr val="3DAA35"/>
           </a:solidFill>
           <a:ln>
             <a:noFill/>
@@ -6657,7 +6829,7 @@
             <a:r>
               <a:rPr sz="1300" b="0" i="0">
                 <a:solidFill>
-                  <a:srgbClr val="FFFFFF"/>
+                  <a:srgbClr val="1A1A2E"/>
                 </a:solidFill>
               </a:rPr>
               <a:t>As we grow our legitimate user base, our SMS costs will scale directly with real human onboarding — not outside bot traffic.
@@ -6681,11 +6853,11 @@
             <a:avLst/>
           </a:prstGeom>
           <a:solidFill>
-            <a:srgbClr val="0F3D6E"/>
+            <a:srgbClr val="EBF7EA"/>
           </a:solidFill>
           <a:ln w="19050">
             <a:solidFill>
-              <a:srgbClr val="E94F37"/>
+              <a:srgbClr val="3DAA35"/>
             </a:solidFill>
           </a:ln>
         </p:spPr>
@@ -6726,7 +6898,7 @@
             <a:avLst/>
           </a:prstGeom>
           <a:solidFill>
-            <a:srgbClr val="E94F37"/>
+            <a:srgbClr val="3DAA35"/>
           </a:solidFill>
           <a:ln>
             <a:noFill/>
@@ -6814,7 +6986,7 @@
             <a:r>
               <a:rPr sz="1300" b="0" i="0">
                 <a:solidFill>
-                  <a:srgbClr val="FFFFFF"/>
+                  <a:srgbClr val="1A1A2E"/>
                 </a:solidFill>
               </a:rPr>
               <a:t>Both security measures happen in milliseconds behind the scenes.
@@ -6838,7 +7010,7 @@
             <a:avLst/>
           </a:prstGeom>
           <a:solidFill>
-            <a:srgbClr val="0F3D6E"/>
+            <a:srgbClr val="F0F0F2"/>
           </a:solidFill>
           <a:ln>
             <a:noFill/>
@@ -6892,7 +7064,7 @@
             <a:r>
               <a:rPr sz="900" b="0" i="0">
                 <a:solidFill>
-                  <a:srgbClr val="CCCCCC"/>
+                  <a:srgbClr val="888899"/>
                 </a:solidFill>
               </a:rPr>
               <a:t>SMS Pumping Defence  |  Confidential</a:t>
@@ -6914,7 +7086,7 @@
     <p:bg>
       <p:bgPr>
         <a:solidFill>
-          <a:srgbClr val="1A1A2E"/>
+          <a:srgbClr val="FFFFFF"/>
         </a:solidFill>
         <a:effectLst/>
       </p:bgPr>
@@ -6941,7 +7113,7 @@
             <a:avLst/>
           </a:prstGeom>
           <a:solidFill>
-            <a:srgbClr val="0F3D6E"/>
+            <a:srgbClr val="3DAA35"/>
           </a:solidFill>
           <a:ln>
             <a:noFill/>
@@ -6977,8 +7149,8 @@
         </p:nvSpPr>
         <p:spPr>
           <a:xfrm>
-            <a:off x="182880" y="73152"/>
-            <a:ext cx="2743200" cy="457200"/>
+            <a:off x="9875520" y="73152"/>
+            <a:ext cx="2103120" cy="457200"/>
           </a:xfrm>
           <a:prstGeom prst="rect">
             <a:avLst/>
@@ -6991,11 +7163,11 @@
           </a:bodyPr>
           <a:lstStyle/>
           <a:p>
-            <a:pPr algn="l"/>
+            <a:pPr algn="r"/>
             <a:r>
               <a:rPr sz="1000" b="0" i="0">
                 <a:solidFill>
-                  <a:srgbClr val="CCCCCC"/>
+                  <a:srgbClr val="FFFFFF"/>
                 </a:solidFill>
               </a:rPr>
               <a:t>Slide 6 of 6</a:t>
@@ -7046,13 +7218,13 @@
         <p:spPr>
           <a:xfrm>
             <a:off x="0" y="658368"/>
-            <a:ext cx="12188952" cy="54864"/>
+            <a:ext cx="12188952" cy="45720"/>
           </a:xfrm>
           <a:prstGeom prst="rect">
             <a:avLst/>
           </a:prstGeom>
           <a:solidFill>
-            <a:srgbClr val="E94F37"/>
+            <a:srgbClr val="1F5C9E"/>
           </a:solidFill>
           <a:ln>
             <a:noFill/>
@@ -7106,7 +7278,7 @@
             <a:r>
               <a:rPr sz="1400" b="0" i="0">
                 <a:solidFill>
-                  <a:srgbClr val="CCCCCC"/>
+                  <a:srgbClr val="555566"/>
                 </a:solidFill>
               </a:rPr>
               <a:t>Every SMS request passes through two automatic checkpoints before we are charged a penny.</a:t>
@@ -7129,11 +7301,11 @@
             <a:avLst/>
           </a:prstGeom>
           <a:solidFill>
-            <a:srgbClr val="0F3D6E"/>
+            <a:srgbClr val="E8F1FB"/>
           </a:solidFill>
           <a:ln w="25400">
             <a:solidFill>
-              <a:srgbClr val="E94F37"/>
+              <a:srgbClr val="1F5C9E"/>
             </a:solidFill>
           </a:ln>
         </p:spPr>
@@ -7185,7 +7357,7 @@
             <a:r>
               <a:rPr sz="1300" b="1" i="0">
                 <a:solidFill>
-                  <a:srgbClr val="FFFFFF"/>
+                  <a:srgbClr val="1F5C9E"/>
                 </a:solidFill>
               </a:rPr>
               <a:t>📲  SMS Request</a:t>
@@ -7219,7 +7391,7 @@
             <a:r>
               <a:rPr sz="1000" b="0" i="0">
                 <a:solidFill>
-                  <a:srgbClr val="CCCCCC"/>
+                  <a:srgbClr val="555566"/>
                 </a:solidFill>
               </a:rPr>
               <a:t>User taps 'Send Code'</a:t>
@@ -7253,7 +7425,7 @@
             <a:r>
               <a:rPr sz="2000" b="0" i="0">
                 <a:solidFill>
-                  <a:srgbClr val="E94F37"/>
+                  <a:srgbClr val="3DAA35"/>
                 </a:solidFill>
               </a:rPr>
               <a:t>➤</a:t>
@@ -7276,11 +7448,11 @@
             <a:avLst/>
           </a:prstGeom>
           <a:solidFill>
-            <a:srgbClr val="14508A"/>
+            <a:srgbClr val="1F5C9E"/>
           </a:solidFill>
           <a:ln w="25400">
             <a:solidFill>
-              <a:srgbClr val="E94F37"/>
+              <a:srgbClr val="1F5C9E"/>
             </a:solidFill>
           </a:ln>
         </p:spPr>
@@ -7366,7 +7538,7 @@
             <a:r>
               <a:rPr sz="1000" b="0" i="0">
                 <a:solidFill>
-                  <a:srgbClr val="CCCCCC"/>
+                  <a:srgbClr val="CCDDFF"/>
                 </a:solidFill>
               </a:rPr>
               <a:t>Is this our real app?</a:t>
@@ -7400,7 +7572,7 @@
             <a:r>
               <a:rPr sz="2000" b="0" i="0">
                 <a:solidFill>
-                  <a:srgbClr val="E94F37"/>
+                  <a:srgbClr val="3DAA35"/>
                 </a:solidFill>
               </a:rPr>
               <a:t>➤</a:t>
@@ -7423,11 +7595,11 @@
             <a:avLst/>
           </a:prstGeom>
           <a:solidFill>
-            <a:srgbClr val="14508A"/>
+            <a:srgbClr val="1F5C9E"/>
           </a:solidFill>
           <a:ln w="25400">
             <a:solidFill>
-              <a:srgbClr val="E94F37"/>
+              <a:srgbClr val="1F5C9E"/>
             </a:solidFill>
           </a:ln>
         </p:spPr>
@@ -7513,7 +7685,7 @@
             <a:r>
               <a:rPr sz="1000" b="0" i="0">
                 <a:solidFill>
-                  <a:srgbClr val="CCCCCC"/>
+                  <a:srgbClr val="CCDDFF"/>
                 </a:solidFill>
               </a:rPr>
               <a:t>Is the request rate normal?</a:t>
@@ -7547,7 +7719,7 @@
             <a:r>
               <a:rPr sz="2000" b="0" i="0">
                 <a:solidFill>
-                  <a:srgbClr val="E94F37"/>
+                  <a:srgbClr val="3DAA35"/>
                 </a:solidFill>
               </a:rPr>
               <a:t>➤</a:t>
@@ -7570,11 +7742,11 @@
             <a:avLst/>
           </a:prstGeom>
           <a:solidFill>
-            <a:srgbClr val="00AA55"/>
+            <a:srgbClr val="3DAA35"/>
           </a:solidFill>
           <a:ln w="25400">
             <a:solidFill>
-              <a:srgbClr val="00FF88"/>
+              <a:srgbClr val="2D8028"/>
             </a:solidFill>
           </a:ln>
         </p:spPr>
@@ -7694,7 +7866,7 @@
             <a:r>
               <a:rPr sz="1600" b="0" i="0">
                 <a:solidFill>
-                  <a:srgbClr val="FF4444"/>
+                  <a:srgbClr val="CC2020"/>
                 </a:solidFill>
               </a:rPr>
               <a:t>▼</a:t>
@@ -7728,7 +7900,7 @@
             <a:r>
               <a:rPr sz="1600" b="0" i="0">
                 <a:solidFill>
-                  <a:srgbClr val="FF4444"/>
+                  <a:srgbClr val="CC2020"/>
                 </a:solidFill>
               </a:rPr>
               <a:t>▼</a:t>
@@ -7751,11 +7923,11 @@
             <a:avLst/>
           </a:prstGeom>
           <a:solidFill>
-            <a:srgbClr val="6B0000"/>
+            <a:srgbClr val="FFEBEB"/>
           </a:solidFill>
           <a:ln w="25400">
             <a:solidFill>
-              <a:srgbClr val="FF4444"/>
+              <a:srgbClr val="CC2020"/>
             </a:solidFill>
           </a:ln>
         </p:spPr>
@@ -7807,7 +7979,7 @@
             <a:r>
               <a:rPr sz="1300" b="1" i="0">
                 <a:solidFill>
-                  <a:srgbClr val="FF4444"/>
+                  <a:srgbClr val="CC2020"/>
                 </a:solidFill>
               </a:rPr>
               <a:t>❌  Blocked — FREE</a:t>
@@ -7841,7 +8013,7 @@
             <a:r>
               <a:rPr sz="1100" b="0" i="0">
                 <a:solidFill>
-                  <a:srgbClr val="CCCCCC"/>
+                  <a:srgbClr val="1A1A2E"/>
                 </a:solidFill>
               </a:rPr>
               <a:t>Bot / script without
@@ -7866,11 +8038,11 @@
             <a:avLst/>
           </a:prstGeom>
           <a:solidFill>
-            <a:srgbClr val="6B0000"/>
+            <a:srgbClr val="FFF3D4"/>
           </a:solidFill>
           <a:ln w="25400">
             <a:solidFill>
-              <a:srgbClr val="FF4444"/>
+              <a:srgbClr val="B86A00"/>
             </a:solidFill>
           </a:ln>
         </p:spPr>
@@ -7922,7 +8094,7 @@
             <a:r>
               <a:rPr sz="1300" b="1" i="0">
                 <a:solidFill>
-                  <a:srgbClr val="FFD700"/>
+                  <a:srgbClr val="B86A00"/>
                 </a:solidFill>
               </a:rPr>
               <a:t>⚠️  Throttled — FREE</a:t>
@@ -7956,7 +8128,7 @@
             <a:r>
               <a:rPr sz="1100" b="0" i="0">
                 <a:solidFill>
-                  <a:srgbClr val="CCCCCC"/>
+                  <a:srgbClr val="1A1A2E"/>
                 </a:solidFill>
               </a:rPr>
               <a:t>Too many requests too fast.
@@ -7981,11 +8153,11 @@
             <a:avLst/>
           </a:prstGeom>
           <a:solidFill>
-            <a:srgbClr val="0F3D6E"/>
+            <a:srgbClr val="EBF7EA"/>
           </a:solidFill>
           <a:ln w="19050">
             <a:solidFill>
-              <a:srgbClr val="FFD700"/>
+              <a:srgbClr val="3DAA35"/>
             </a:solidFill>
           </a:ln>
         </p:spPr>
@@ -8037,7 +8209,7 @@
             <a:r>
               <a:rPr sz="1400" b="1" i="0">
                 <a:solidFill>
-                  <a:srgbClr val="FFD700"/>
+                  <a:srgbClr val="2D8028"/>
                 </a:solidFill>
               </a:rPr>
               <a:t>🔑  Key Takeaway for the Business</a:t>
@@ -8075,7 +8247,7 @@
             <a:r>
               <a:rPr sz="1200">
                 <a:solidFill>
-                  <a:srgbClr val="FFFFFF"/>
+                  <a:srgbClr val="1A1A2E"/>
                 </a:solidFill>
               </a:rPr>
               <a:t>✔  Only real users on our genuine app can ever reach the 'SMS Sent' step — protecting our budget automatically.</a:t>
@@ -8090,7 +8262,7 @@
             <a:r>
               <a:rPr sz="1200">
                 <a:solidFill>
-                  <a:srgbClr val="FFFFFF"/>
+                  <a:srgbClr val="1A1A2E"/>
                 </a:solidFill>
               </a:rPr>
               <a:t>✔  The system is fully invisible to legitimate customers and requires no manual intervention.</a:t>
@@ -8105,7 +8277,7 @@
             <a:r>
               <a:rPr sz="1200">
                 <a:solidFill>
-                  <a:srgbClr val="FFFFFF"/>
+                  <a:srgbClr val="1A1A2E"/>
                 </a:solidFill>
               </a:rPr>
               <a:t>✔  Both checkpoints run in under 50 milliseconds — no perceptible delay for users.</a:t>
@@ -8128,7 +8300,7 @@
             <a:avLst/>
           </a:prstGeom>
           <a:solidFill>
-            <a:srgbClr val="0F3D6E"/>
+            <a:srgbClr val="F0F0F2"/>
           </a:solidFill>
           <a:ln>
             <a:noFill/>
@@ -8182,7 +8354,7 @@
             <a:r>
               <a:rPr sz="900" b="0" i="0">
                 <a:solidFill>
-                  <a:srgbClr val="CCCCCC"/>
+                  <a:srgbClr val="888899"/>
                 </a:solidFill>
               </a:rPr>
               <a:t>SMS Pumping Defence  |  Confidential</a:t>

</xml_diff>

<commit_message>
Update sms_pumping_defence.pptx to use SOLEVO brand colors
Co-authored-by: labanlaban <126345013+labanlaban@users.noreply.github.com>
</commit_message>
<xml_diff>
--- a/sms_pumping_defence.pptx
+++ b/sms_pumping_defence.pptx
@@ -3548,7 +3548,7 @@
             <a:avLst/>
           </a:prstGeom>
           <a:solidFill>
-            <a:srgbClr val="E94F37"/>
+            <a:srgbClr val="3DAE2B"/>
           </a:solidFill>
           <a:ln>
             <a:noFill/>
@@ -3596,7 +3596,7 @@
           </a:solidFill>
           <a:ln w="19050">
             <a:solidFill>
-              <a:srgbClr val="E94F37"/>
+              <a:srgbClr val="3DAE2B"/>
             </a:solidFill>
           </a:ln>
         </p:spPr>
@@ -3649,7 +3649,7 @@
             <a:r>
               <a:rPr sz="1500" b="1" i="0">
                 <a:solidFill>
-                  <a:srgbClr val="FFD700"/>
+                  <a:srgbClr val="3DAE2B"/>
                 </a:solidFill>
               </a:rPr>
               <a:t>📌  The Situation</a:t>
@@ -3710,7 +3710,7 @@
           </a:solidFill>
           <a:ln w="19050">
             <a:solidFill>
-              <a:srgbClr val="E94F37"/>
+              <a:srgbClr val="3DAE2B"/>
             </a:solidFill>
           </a:ln>
         </p:spPr>
@@ -3763,7 +3763,7 @@
             <a:r>
               <a:rPr sz="1500" b="1" i="0">
                 <a:solidFill>
-                  <a:srgbClr val="FFD700"/>
+                  <a:srgbClr val="3DAE2B"/>
                 </a:solidFill>
               </a:rPr>
               <a:t>⚠️  The Problem</a:t>
@@ -3824,7 +3824,7 @@
           </a:solidFill>
           <a:ln w="19050">
             <a:solidFill>
-              <a:srgbClr val="E94F37"/>
+              <a:srgbClr val="3DAE2B"/>
             </a:solidFill>
           </a:ln>
         </p:spPr>
@@ -3877,7 +3877,7 @@
             <a:r>
               <a:rPr sz="1500" b="1" i="0">
                 <a:solidFill>
-                  <a:srgbClr val="FFD700"/>
+                  <a:srgbClr val="3DAE2B"/>
                 </a:solidFill>
               </a:rPr>
               <a:t>🔍  The Root Cause</a:t>
@@ -3954,7 +3954,7 @@
           </a:solidFill>
           <a:ln w="19050">
             <a:solidFill>
-              <a:srgbClr val="E94F37"/>
+              <a:srgbClr val="3DAE2B"/>
             </a:solidFill>
           </a:ln>
         </p:spPr>
@@ -4007,7 +4007,7 @@
             <a:r>
               <a:rPr sz="1500" b="1" i="0">
                 <a:solidFill>
-                  <a:srgbClr val="FFD700"/>
+                  <a:srgbClr val="3DAE2B"/>
                 </a:solidFill>
               </a:rPr>
               <a:t>🤖  What This Is</a:t>
@@ -4293,7 +4293,7 @@
             <a:avLst/>
           </a:prstGeom>
           <a:solidFill>
-            <a:srgbClr val="E94F37"/>
+            <a:srgbClr val="3DAE2B"/>
           </a:solidFill>
           <a:ln>
             <a:noFill/>
@@ -4382,7 +4382,7 @@
             <a:r>
               <a:rPr sz="1500" b="1" i="0" dirty="0">
                 <a:solidFill>
-                  <a:srgbClr val="FFD700"/>
+                  <a:srgbClr val="3DAE2B"/>
                 </a:solidFill>
               </a:rPr>
               <a:t>Both layers must be passed before we spend a single cent on an SMS.</a:t>
@@ -4409,7 +4409,7 @@
           </a:solidFill>
           <a:ln w="25400">
             <a:solidFill>
-              <a:srgbClr val="E94F37"/>
+              <a:srgbClr val="3DAE2B"/>
             </a:solidFill>
           </a:ln>
         </p:spPr>
@@ -4451,7 +4451,7 @@
             <a:avLst/>
           </a:prstGeom>
           <a:solidFill>
-            <a:srgbClr val="E94F37"/>
+            <a:srgbClr val="3DAE2B"/>
           </a:solidFill>
           <a:ln>
             <a:noFill/>
@@ -4585,7 +4585,7 @@
           </a:solidFill>
           <a:ln w="25400">
             <a:solidFill>
-              <a:srgbClr val="E94F37"/>
+              <a:srgbClr val="3DAE2B"/>
             </a:solidFill>
           </a:ln>
         </p:spPr>
@@ -4627,7 +4627,7 @@
             <a:avLst/>
           </a:prstGeom>
           <a:solidFill>
-            <a:srgbClr val="E94F37"/>
+            <a:srgbClr val="3DAE2B"/>
           </a:solidFill>
           <a:ln>
             <a:noFill/>
@@ -4946,7 +4946,7 @@
             <a:avLst/>
           </a:prstGeom>
           <a:solidFill>
-            <a:srgbClr val="E94F37"/>
+            <a:srgbClr val="3DAE2B"/>
           </a:solidFill>
           <a:ln>
             <a:noFill/>
@@ -5001,7 +5001,7 @@
             <a:r>
               <a:rPr sz="1800" b="1" i="0" dirty="0">
                 <a:solidFill>
-                  <a:srgbClr val="FFD700"/>
+                  <a:srgbClr val="3DAE2B"/>
                 </a:solidFill>
               </a:rPr>
               <a:t>🔒  </a:t>
@@ -5009,7 +5009,7 @@
             <a:r>
               <a:rPr sz="1800" b="1" i="0" dirty="0" err="1">
                 <a:solidFill>
-                  <a:srgbClr val="FFD700"/>
+                  <a:srgbClr val="3DAE2B"/>
                 </a:solidFill>
               </a:rPr>
               <a:t>AppRequestContextFilter</a:t>
@@ -5017,7 +5017,7 @@
             <a:r>
               <a:rPr sz="1800" b="1" i="0" dirty="0">
                 <a:solidFill>
-                  <a:srgbClr val="FFD700"/>
+                  <a:srgbClr val="3DAE2B"/>
                 </a:solidFill>
               </a:rPr>
               <a:t>  (Firebase App Check)</a:t>
@@ -5044,7 +5044,7 @@
           </a:solidFill>
           <a:ln w="25400">
             <a:solidFill>
-              <a:srgbClr val="E94F37"/>
+              <a:srgbClr val="3DAE2B"/>
             </a:solidFill>
           </a:ln>
         </p:spPr>
@@ -5176,7 +5176,7 @@
           </a:solidFill>
           <a:ln w="25400">
             <a:solidFill>
-              <a:srgbClr val="E94F37"/>
+              <a:srgbClr val="3DAE2B"/>
             </a:solidFill>
           </a:ln>
         </p:spPr>
@@ -5288,11 +5288,11 @@
             <a:avLst/>
           </a:prstGeom>
           <a:solidFill>
-            <a:srgbClr val="8B0000"/>
+            <a:srgbClr val="0F3D6E"/>
           </a:solidFill>
           <a:ln w="25400">
             <a:solidFill>
-              <a:srgbClr val="FF4444"/>
+              <a:srgbClr val="2E5FA3"/>
             </a:solidFill>
           </a:ln>
         </p:spPr>
@@ -5345,7 +5345,7 @@
             <a:r>
               <a:rPr sz="1400" b="1" i="0">
                 <a:solidFill>
-                  <a:srgbClr val="FFD700"/>
+                  <a:srgbClr val="3DAE2B"/>
                 </a:solidFill>
               </a:rPr>
               <a:t>🤖  Bot / Script</a:t>
@@ -5415,7 +5415,7 @@
             <a:r>
               <a:rPr sz="2200" b="0" i="0">
                 <a:solidFill>
-                  <a:srgbClr val="E94F37"/>
+                  <a:srgbClr val="3DAE2B"/>
                 </a:solidFill>
               </a:rPr>
               <a:t>➤</a:t>
@@ -5449,7 +5449,7 @@
             <a:r>
               <a:rPr sz="2200" b="0" i="0">
                 <a:solidFill>
-                  <a:srgbClr val="E94F37"/>
+                  <a:srgbClr val="3DAE2B"/>
                 </a:solidFill>
               </a:rPr>
               <a:t>➤</a:t>
@@ -5472,11 +5472,11 @@
             <a:avLst/>
           </a:prstGeom>
           <a:solidFill>
-            <a:srgbClr val="E94F37"/>
+            <a:srgbClr val="3DAE2B"/>
           </a:solidFill>
           <a:ln>
             <a:solidFill>
-              <a:srgbClr val="E94F37"/>
+              <a:srgbClr val="3DAE2B"/>
             </a:solidFill>
           </a:ln>
         </p:spPr>
@@ -5841,7 +5841,7 @@
             <a:avLst/>
           </a:prstGeom>
           <a:solidFill>
-            <a:srgbClr val="E94F37"/>
+            <a:srgbClr val="3DAE2B"/>
           </a:solidFill>
           <a:ln>
             <a:noFill/>
@@ -5896,7 +5896,7 @@
             <a:r>
               <a:rPr sz="1800" b="1" i="0">
                 <a:solidFill>
-                  <a:srgbClr val="FFD700"/>
+                  <a:srgbClr val="3DAE2B"/>
                 </a:solidFill>
               </a:rPr>
               <a:t>⏱️  SendOtpRateLimitAttribute</a:t>
@@ -5923,7 +5923,7 @@
           </a:solidFill>
           <a:ln w="19050">
             <a:solidFill>
-              <a:srgbClr val="E94F37"/>
+              <a:srgbClr val="3DAE2B"/>
             </a:solidFill>
           </a:ln>
         </p:spPr>
@@ -5965,7 +5965,7 @@
             <a:avLst/>
           </a:prstGeom>
           <a:solidFill>
-            <a:srgbClr val="E94F37"/>
+            <a:srgbClr val="3DAE2B"/>
           </a:solidFill>
           <a:ln>
             <a:noFill/>
@@ -6098,7 +6098,7 @@
           </a:solidFill>
           <a:ln w="19050">
             <a:solidFill>
-              <a:srgbClr val="E94F37"/>
+              <a:srgbClr val="3DAE2B"/>
             </a:solidFill>
           </a:ln>
         </p:spPr>
@@ -6140,7 +6140,7 @@
             <a:avLst/>
           </a:prstGeom>
           <a:solidFill>
-            <a:srgbClr val="E94F37"/>
+            <a:srgbClr val="3DAE2B"/>
           </a:solidFill>
           <a:ln>
             <a:noFill/>
@@ -6303,7 +6303,7 @@
           </a:solidFill>
           <a:ln w="19050">
             <a:solidFill>
-              <a:srgbClr val="E94F37"/>
+              <a:srgbClr val="3DAE2B"/>
             </a:solidFill>
           </a:ln>
         </p:spPr>
@@ -6345,7 +6345,7 @@
             <a:avLst/>
           </a:prstGeom>
           <a:solidFill>
-            <a:srgbClr val="E94F37"/>
+            <a:srgbClr val="3DAE2B"/>
           </a:solidFill>
           <a:ln>
             <a:noFill/>
@@ -6479,7 +6479,7 @@
           </a:solidFill>
           <a:ln w="19050">
             <a:solidFill>
-              <a:srgbClr val="FFD700"/>
+              <a:srgbClr val="3DAE2B"/>
             </a:solidFill>
           </a:ln>
         </p:spPr>
@@ -6532,7 +6532,7 @@
             <a:r>
               <a:rPr sz="1400" b="1" i="0" dirty="0">
                 <a:solidFill>
-                  <a:srgbClr val="FFD700"/>
+                  <a:srgbClr val="3DAE2B"/>
                 </a:solidFill>
               </a:rPr>
               <a:t>🔐  Combined Defense Summary</a:t>
@@ -6797,7 +6797,7 @@
             <a:avLst/>
           </a:prstGeom>
           <a:solidFill>
-            <a:srgbClr val="E94F37"/>
+            <a:srgbClr val="3DAE2B"/>
           </a:solidFill>
           <a:ln>
             <a:noFill/>
@@ -6845,7 +6845,7 @@
           </a:solidFill>
           <a:ln w="19050">
             <a:solidFill>
-              <a:srgbClr val="E94F37"/>
+              <a:srgbClr val="3DAE2B"/>
             </a:solidFill>
           </a:ln>
         </p:spPr>
@@ -6887,7 +6887,7 @@
             <a:avLst/>
           </a:prstGeom>
           <a:solidFill>
-            <a:srgbClr val="E94F37"/>
+            <a:srgbClr val="3DAE2B"/>
           </a:solidFill>
           <a:ln>
             <a:noFill/>
@@ -7004,7 +7004,7 @@
           </a:solidFill>
           <a:ln w="19050">
             <a:solidFill>
-              <a:srgbClr val="E94F37"/>
+              <a:srgbClr val="3DAE2B"/>
             </a:solidFill>
           </a:ln>
         </p:spPr>
@@ -7046,7 +7046,7 @@
             <a:avLst/>
           </a:prstGeom>
           <a:solidFill>
-            <a:srgbClr val="E94F37"/>
+            <a:srgbClr val="3DAE2B"/>
           </a:solidFill>
           <a:ln>
             <a:noFill/>
@@ -7179,7 +7179,7 @@
           </a:solidFill>
           <a:ln w="19050">
             <a:solidFill>
-              <a:srgbClr val="E94F37"/>
+              <a:srgbClr val="3DAE2B"/>
             </a:solidFill>
           </a:ln>
         </p:spPr>
@@ -7221,7 +7221,7 @@
             <a:avLst/>
           </a:prstGeom>
           <a:solidFill>
-            <a:srgbClr val="E94F37"/>
+            <a:srgbClr val="3DAE2B"/>
           </a:solidFill>
           <a:ln>
             <a:noFill/>
@@ -7539,7 +7539,7 @@
             <a:avLst/>
           </a:prstGeom>
           <a:solidFill>
-            <a:srgbClr val="E94F37"/>
+            <a:srgbClr val="3DAE2B"/>
           </a:solidFill>
           <a:ln>
             <a:noFill/>
@@ -7621,7 +7621,7 @@
           </a:solidFill>
           <a:ln w="25400">
             <a:solidFill>
-              <a:srgbClr val="E94F37"/>
+              <a:srgbClr val="3DAE2B"/>
             </a:solidFill>
           </a:ln>
         </p:spPr>
@@ -7742,7 +7742,7 @@
             <a:r>
               <a:rPr sz="2000" b="0" i="0">
                 <a:solidFill>
-                  <a:srgbClr val="E94F37"/>
+                  <a:srgbClr val="3DAE2B"/>
                 </a:solidFill>
               </a:rPr>
               <a:t>➤</a:t>
@@ -7765,11 +7765,11 @@
             <a:avLst/>
           </a:prstGeom>
           <a:solidFill>
-            <a:srgbClr val="14508A"/>
+            <a:srgbClr val="2E5FA3"/>
           </a:solidFill>
           <a:ln w="25400">
             <a:solidFill>
-              <a:srgbClr val="E94F37"/>
+              <a:srgbClr val="3DAE2B"/>
             </a:solidFill>
           </a:ln>
         </p:spPr>
@@ -7890,7 +7890,7 @@
             <a:r>
               <a:rPr sz="2000" b="0" i="0">
                 <a:solidFill>
-                  <a:srgbClr val="E94F37"/>
+                  <a:srgbClr val="3DAE2B"/>
                 </a:solidFill>
               </a:rPr>
               <a:t>➤</a:t>
@@ -7913,11 +7913,11 @@
             <a:avLst/>
           </a:prstGeom>
           <a:solidFill>
-            <a:srgbClr val="14508A"/>
+            <a:srgbClr val="2E5FA3"/>
           </a:solidFill>
           <a:ln w="25400">
             <a:solidFill>
-              <a:srgbClr val="E94F37"/>
+              <a:srgbClr val="3DAE2B"/>
             </a:solidFill>
           </a:ln>
         </p:spPr>
@@ -8038,7 +8038,7 @@
             <a:r>
               <a:rPr sz="2000" b="0" i="0">
                 <a:solidFill>
-                  <a:srgbClr val="E94F37"/>
+                  <a:srgbClr val="3DAE2B"/>
                 </a:solidFill>
               </a:rPr>
               <a:t>➤</a:t>
@@ -8061,11 +8061,11 @@
             <a:avLst/>
           </a:prstGeom>
           <a:solidFill>
-            <a:srgbClr val="00AA55"/>
+            <a:srgbClr val="3DAE2B"/>
           </a:solidFill>
           <a:ln w="25400">
             <a:solidFill>
-              <a:srgbClr val="00FF88"/>
+              <a:srgbClr val="3DAE2B"/>
             </a:solidFill>
           </a:ln>
         </p:spPr>
@@ -8152,7 +8152,7 @@
             <a:r>
               <a:rPr sz="1000" b="0" i="0" dirty="0">
                 <a:solidFill>
-                  <a:srgbClr val="CCFFCC"/>
+                  <a:srgbClr val="FFFFFF"/>
                 </a:solidFill>
               </a:rPr>
               <a:t>Twilio charged </a:t>
@@ -8160,7 +8160,7 @@
             <a:r>
               <a:rPr lang="en-US" sz="1000" b="0" i="0" dirty="0">
                 <a:solidFill>
-                  <a:srgbClr val="CCFFCC"/>
+                  <a:srgbClr val="FFFFFF"/>
                 </a:solidFill>
               </a:rPr>
               <a:t>since it’s a</a:t>
@@ -8171,7 +8171,7 @@
             <a:r>
               <a:rPr sz="1000" b="0" i="0" dirty="0">
                 <a:solidFill>
-                  <a:srgbClr val="CCFFCC"/>
+                  <a:srgbClr val="FFFFFF"/>
                 </a:solidFill>
               </a:rPr>
               <a:t> legitimate user</a:t>
@@ -8205,7 +8205,7 @@
             <a:r>
               <a:rPr sz="1600" b="0" i="0">
                 <a:solidFill>
-                  <a:srgbClr val="FF4444"/>
+                  <a:srgbClr val="2E5FA3"/>
                 </a:solidFill>
               </a:rPr>
               <a:t>▼</a:t>
@@ -8239,7 +8239,7 @@
             <a:r>
               <a:rPr sz="1600" b="0" i="0">
                 <a:solidFill>
-                  <a:srgbClr val="FF4444"/>
+                  <a:srgbClr val="2E5FA3"/>
                 </a:solidFill>
               </a:rPr>
               <a:t>▼</a:t>
@@ -8262,11 +8262,11 @@
             <a:avLst/>
           </a:prstGeom>
           <a:solidFill>
-            <a:srgbClr val="6B0000"/>
+            <a:srgbClr val="0F3D6E"/>
           </a:solidFill>
           <a:ln w="25400">
             <a:solidFill>
-              <a:srgbClr val="FF4444"/>
+              <a:srgbClr val="2E5FA3"/>
             </a:solidFill>
           </a:ln>
         </p:spPr>
@@ -8319,7 +8319,7 @@
             <a:r>
               <a:rPr sz="1300" b="1" i="0">
                 <a:solidFill>
-                  <a:srgbClr val="FF4444"/>
+                  <a:srgbClr val="2E5FA3"/>
                 </a:solidFill>
               </a:rPr>
               <a:t>❌  Blocked — FREE</a:t>
@@ -8378,11 +8378,11 @@
             <a:avLst/>
           </a:prstGeom>
           <a:solidFill>
-            <a:srgbClr val="6B0000"/>
+            <a:srgbClr val="0F3D6E"/>
           </a:solidFill>
           <a:ln w="25400">
             <a:solidFill>
-              <a:srgbClr val="FF4444"/>
+              <a:srgbClr val="2E5FA3"/>
             </a:solidFill>
           </a:ln>
         </p:spPr>
@@ -8435,7 +8435,7 @@
             <a:r>
               <a:rPr sz="1300" b="1" i="0">
                 <a:solidFill>
-                  <a:srgbClr val="FFD700"/>
+                  <a:srgbClr val="3DAE2B"/>
                 </a:solidFill>
               </a:rPr>
               <a:t>⚠️  Throttled — FREE</a:t>
@@ -8529,7 +8529,7 @@
           </a:solidFill>
           <a:ln w="19050">
             <a:solidFill>
-              <a:srgbClr val="FFD700"/>
+              <a:srgbClr val="3DAE2B"/>
             </a:solidFill>
           </a:ln>
         </p:spPr>
@@ -8582,7 +8582,7 @@
             <a:r>
               <a:rPr sz="1400" b="1" i="0">
                 <a:solidFill>
-                  <a:srgbClr val="FFD700"/>
+                  <a:srgbClr val="3DAE2B"/>
                 </a:solidFill>
               </a:rPr>
               <a:t>🔑  Key Takeaway for the Business</a:t>

</xml_diff>